<commit_message>
Reorganize project: clean up root, update README in Japanese
- Move main.py and generate_slides.py to tools/
- Delete unused files: style.css, x-header.html, x-profile.html
- Remove contract PDF from git tracking (covered by .gitignore)
- Rewrite README.md in Japanese with full project overview

Co-Authored-By: Claude Sonnet 4.6 <noreply@anthropic.com>
</commit_message>
<xml_diff>
--- a/departments/sales/emport-ai-seminar-slides.pptx
+++ b/departments/sales/emport-ai-seminar-slides.pptx
@@ -4,24 +4,27 @@
   <p:sldMasterIdLst>
     <p:sldMasterId id="2147483648" r:id="rId1"/>
   </p:sldMasterIdLst>
+  <p:notesMasterIdLst>
+    <p:notesMasterId r:id="rId17"/>
+  </p:notesMasterIdLst>
   <p:sldIdLst>
-    <p:sldId id="256" r:id="rId7"/>
-    <p:sldId id="257" r:id="rId8"/>
-    <p:sldId id="258" r:id="rId9"/>
-    <p:sldId id="259" r:id="rId10"/>
-    <p:sldId id="260" r:id="rId11"/>
-    <p:sldId id="261" r:id="rId12"/>
-    <p:sldId id="262" r:id="rId13"/>
-    <p:sldId id="263" r:id="rId14"/>
-    <p:sldId id="264" r:id="rId15"/>
-    <p:sldId id="265" r:id="rId16"/>
-    <p:sldId id="266" r:id="rId17"/>
-    <p:sldId id="267" r:id="rId18"/>
-    <p:sldId id="268" r:id="rId19"/>
-    <p:sldId id="269" r:id="rId20"/>
-    <p:sldId id="270" r:id="rId21"/>
+    <p:sldId id="256" r:id="rId2"/>
+    <p:sldId id="257" r:id="rId3"/>
+    <p:sldId id="258" r:id="rId4"/>
+    <p:sldId id="259" r:id="rId5"/>
+    <p:sldId id="260" r:id="rId6"/>
+    <p:sldId id="261" r:id="rId7"/>
+    <p:sldId id="262" r:id="rId8"/>
+    <p:sldId id="263" r:id="rId9"/>
+    <p:sldId id="264" r:id="rId10"/>
+    <p:sldId id="265" r:id="rId11"/>
+    <p:sldId id="266" r:id="rId12"/>
+    <p:sldId id="267" r:id="rId13"/>
+    <p:sldId id="268" r:id="rId14"/>
+    <p:sldId id="269" r:id="rId15"/>
+    <p:sldId id="270" r:id="rId16"/>
   </p:sldIdLst>
-  <p:sldSz cx="12188952" cy="6858000" type="screen4x3"/>
+  <p:sldSz cx="12188825" cy="6858000"/>
   <p:notesSz cx="6858000" cy="9144000"/>
   <p:defaultTextStyle>
     <a:defPPr>
@@ -118,7 +121,525 @@
       </a:defRPr>
     </a:lvl9pPr>
   </p:defaultTextStyle>
+  <p:extLst>
+    <p:ext uri="{EFAFB233-063F-42B5-8137-9DF3F51BA10A}">
+      <p15:sldGuideLst xmlns:p15="http://schemas.microsoft.com/office/powerpoint/2012/main">
+        <p15:guide id="1" orient="horz" pos="2160">
+          <p15:clr>
+            <a:srgbClr val="A4A3A4"/>
+          </p15:clr>
+        </p15:guide>
+        <p15:guide id="2" pos="2880">
+          <p15:clr>
+            <a:srgbClr val="A4A3A4"/>
+          </p15:clr>
+        </p15:guide>
+      </p15:sldGuideLst>
+    </p:ext>
+  </p:extLst>
 </p:presentation>
+</file>
+
+<file path=ppt/changesInfos/changesInfo1.xml><?xml version="1.0" encoding="utf-8"?>
+<pc:chgInfo xmlns:a="http://schemas.openxmlformats.org/drawingml/2006/main" xmlns:r="http://schemas.openxmlformats.org/officeDocument/2006/relationships" xmlns:ac="http://schemas.microsoft.com/office/drawing/2013/main/command" xmlns:pc="http://schemas.microsoft.com/office/powerpoint/2013/main/command">
+  <pc:docChgLst>
+    <pc:chgData name="悠清 田中" userId="2f927e6e73b3de81" providerId="LiveId" clId="{521E58F1-265D-4515-BB0F-11149DE31DE0}"/>
+    <pc:docChg chg="modSld">
+      <pc:chgData name="悠清 田中" userId="2f927e6e73b3de81" providerId="LiveId" clId="{521E58F1-265D-4515-BB0F-11149DE31DE0}" dt="2026-04-21T21:16:32.570" v="1" actId="1076"/>
+      <pc:docMkLst>
+        <pc:docMk/>
+      </pc:docMkLst>
+      <pc:sldChg chg="modSp mod">
+        <pc:chgData name="悠清 田中" userId="2f927e6e73b3de81" providerId="LiveId" clId="{521E58F1-265D-4515-BB0F-11149DE31DE0}" dt="2026-04-21T21:16:32.570" v="1" actId="1076"/>
+        <pc:sldMkLst>
+          <pc:docMk/>
+          <pc:sldMk cId="0" sldId="267"/>
+        </pc:sldMkLst>
+        <pc:spChg chg="mod">
+          <ac:chgData name="悠清 田中" userId="2f927e6e73b3de81" providerId="LiveId" clId="{521E58F1-265D-4515-BB0F-11149DE31DE0}" dt="2026-04-21T21:16:30.051" v="0" actId="1076"/>
+          <ac:spMkLst>
+            <pc:docMk/>
+            <pc:sldMk cId="0" sldId="267"/>
+            <ac:spMk id="19" creationId="{00000000-0000-0000-0000-000000000000}"/>
+          </ac:spMkLst>
+        </pc:spChg>
+        <pc:spChg chg="mod">
+          <ac:chgData name="悠清 田中" userId="2f927e6e73b3de81" providerId="LiveId" clId="{521E58F1-265D-4515-BB0F-11149DE31DE0}" dt="2026-04-21T21:16:32.570" v="1" actId="1076"/>
+          <ac:spMkLst>
+            <pc:docMk/>
+            <pc:sldMk cId="0" sldId="267"/>
+            <ac:spMk id="20" creationId="{00000000-0000-0000-0000-000000000000}"/>
+          </ac:spMkLst>
+        </pc:spChg>
+      </pc:sldChg>
+    </pc:docChg>
+  </pc:docChgLst>
+</pc:chgInfo>
+</file>
+
+<file path=ppt/notesMasters/notesMaster1.xml><?xml version="1.0" encoding="utf-8"?>
+<p:notesMaster xmlns:a="http://schemas.openxmlformats.org/drawingml/2006/main" xmlns:r="http://schemas.openxmlformats.org/officeDocument/2006/relationships" xmlns:p="http://schemas.openxmlformats.org/presentationml/2006/main">
+  <p:cSld>
+    <p:bg>
+      <p:bgRef idx="1001">
+        <a:schemeClr val="bg1"/>
+      </p:bgRef>
+    </p:bg>
+    <p:spTree>
+      <p:nvGrpSpPr>
+        <p:cNvPr id="1" name=""/>
+        <p:cNvGrpSpPr/>
+        <p:nvPr/>
+      </p:nvGrpSpPr>
+      <p:grpSpPr>
+        <a:xfrm>
+          <a:off x="0" y="0"/>
+          <a:ext cx="0" cy="0"/>
+          <a:chOff x="0" y="0"/>
+          <a:chExt cx="0" cy="0"/>
+        </a:xfrm>
+      </p:grpSpPr>
+      <p:sp>
+        <p:nvSpPr>
+          <p:cNvPr id="2" name="ヘッダー プレースホルダー 1"/>
+          <p:cNvSpPr>
+            <a:spLocks noGrp="1"/>
+          </p:cNvSpPr>
+          <p:nvPr>
+            <p:ph type="hdr" sz="quarter"/>
+          </p:nvPr>
+        </p:nvSpPr>
+        <p:spPr>
+          <a:xfrm>
+            <a:off x="0" y="0"/>
+            <a:ext cx="2971800" cy="458788"/>
+          </a:xfrm>
+          <a:prstGeom prst="rect">
+            <a:avLst/>
+          </a:prstGeom>
+        </p:spPr>
+        <p:txBody>
+          <a:bodyPr vert="horz" lIns="91440" tIns="45720" rIns="91440" bIns="45720" rtlCol="0"/>
+          <a:lstStyle>
+            <a:lvl1pPr algn="l">
+              <a:defRPr sz="1200"/>
+            </a:lvl1pPr>
+          </a:lstStyle>
+          <a:p>
+            <a:endParaRPr kumimoji="1" lang="ja-JP" altLang="en-US"/>
+          </a:p>
+        </p:txBody>
+      </p:sp>
+      <p:sp>
+        <p:nvSpPr>
+          <p:cNvPr id="3" name="日付プレースホルダー 2"/>
+          <p:cNvSpPr>
+            <a:spLocks noGrp="1"/>
+          </p:cNvSpPr>
+          <p:nvPr>
+            <p:ph type="dt" idx="1"/>
+          </p:nvPr>
+        </p:nvSpPr>
+        <p:spPr>
+          <a:xfrm>
+            <a:off x="3884613" y="0"/>
+            <a:ext cx="2971800" cy="458788"/>
+          </a:xfrm>
+          <a:prstGeom prst="rect">
+            <a:avLst/>
+          </a:prstGeom>
+        </p:spPr>
+        <p:txBody>
+          <a:bodyPr vert="horz" lIns="91440" tIns="45720" rIns="91440" bIns="45720" rtlCol="0"/>
+          <a:lstStyle>
+            <a:lvl1pPr algn="r">
+              <a:defRPr sz="1200"/>
+            </a:lvl1pPr>
+          </a:lstStyle>
+          <a:p>
+            <a:fld id="{0421DB69-A82F-4D30-9F9E-9BD48DDCECC7}" type="datetimeFigureOut">
+              <a:rPr kumimoji="1" lang="ja-JP" altLang="en-US" smtClean="0"/>
+              <a:t>2026/4/22</a:t>
+            </a:fld>
+            <a:endParaRPr kumimoji="1" lang="ja-JP" altLang="en-US"/>
+          </a:p>
+        </p:txBody>
+      </p:sp>
+      <p:sp>
+        <p:nvSpPr>
+          <p:cNvPr id="4" name="スライド イメージ プレースホルダー 3"/>
+          <p:cNvSpPr>
+            <a:spLocks noGrp="1" noRot="1" noChangeAspect="1"/>
+          </p:cNvSpPr>
+          <p:nvPr>
+            <p:ph type="sldImg" idx="2"/>
+          </p:nvPr>
+        </p:nvSpPr>
+        <p:spPr>
+          <a:xfrm>
+            <a:off x="685800" y="1143000"/>
+            <a:ext cx="5486400" cy="3086100"/>
+          </a:xfrm>
+          <a:prstGeom prst="rect">
+            <a:avLst/>
+          </a:prstGeom>
+          <a:noFill/>
+          <a:ln w="12700">
+            <a:solidFill>
+              <a:prstClr val="black"/>
+            </a:solidFill>
+          </a:ln>
+        </p:spPr>
+        <p:txBody>
+          <a:bodyPr vert="horz" lIns="91440" tIns="45720" rIns="91440" bIns="45720" rtlCol="0" anchor="ctr"/>
+          <a:lstStyle/>
+          <a:p>
+            <a:endParaRPr lang="ja-JP" altLang="en-US"/>
+          </a:p>
+        </p:txBody>
+      </p:sp>
+      <p:sp>
+        <p:nvSpPr>
+          <p:cNvPr id="5" name="ノート プレースホルダー 4"/>
+          <p:cNvSpPr>
+            <a:spLocks noGrp="1"/>
+          </p:cNvSpPr>
+          <p:nvPr>
+            <p:ph type="body" sz="quarter" idx="3"/>
+          </p:nvPr>
+        </p:nvSpPr>
+        <p:spPr>
+          <a:xfrm>
+            <a:off x="685800" y="4400550"/>
+            <a:ext cx="5486400" cy="3600450"/>
+          </a:xfrm>
+          <a:prstGeom prst="rect">
+            <a:avLst/>
+          </a:prstGeom>
+        </p:spPr>
+        <p:txBody>
+          <a:bodyPr vert="horz" lIns="91440" tIns="45720" rIns="91440" bIns="45720" rtlCol="0"/>
+          <a:lstStyle/>
+          <a:p>
+            <a:pPr lvl="0"/>
+            <a:r>
+              <a:rPr kumimoji="1" lang="ja-JP" altLang="en-US"/>
+              <a:t>マスター テキストの書式設定</a:t>
+            </a:r>
+          </a:p>
+          <a:p>
+            <a:pPr lvl="1"/>
+            <a:r>
+              <a:rPr kumimoji="1" lang="ja-JP" altLang="en-US"/>
+              <a:t>第 </a:t>
+            </a:r>
+            <a:r>
+              <a:rPr kumimoji="1" lang="en-US" altLang="ja-JP"/>
+              <a:t>2 </a:t>
+            </a:r>
+            <a:r>
+              <a:rPr kumimoji="1" lang="ja-JP" altLang="en-US"/>
+              <a:t>レベル</a:t>
+            </a:r>
+          </a:p>
+          <a:p>
+            <a:pPr lvl="2"/>
+            <a:r>
+              <a:rPr kumimoji="1" lang="ja-JP" altLang="en-US"/>
+              <a:t>第 </a:t>
+            </a:r>
+            <a:r>
+              <a:rPr kumimoji="1" lang="en-US" altLang="ja-JP"/>
+              <a:t>3 </a:t>
+            </a:r>
+            <a:r>
+              <a:rPr kumimoji="1" lang="ja-JP" altLang="en-US"/>
+              <a:t>レベル</a:t>
+            </a:r>
+          </a:p>
+          <a:p>
+            <a:pPr lvl="3"/>
+            <a:r>
+              <a:rPr kumimoji="1" lang="ja-JP" altLang="en-US"/>
+              <a:t>第 </a:t>
+            </a:r>
+            <a:r>
+              <a:rPr kumimoji="1" lang="en-US" altLang="ja-JP"/>
+              <a:t>4 </a:t>
+            </a:r>
+            <a:r>
+              <a:rPr kumimoji="1" lang="ja-JP" altLang="en-US"/>
+              <a:t>レベル</a:t>
+            </a:r>
+          </a:p>
+          <a:p>
+            <a:pPr lvl="4"/>
+            <a:r>
+              <a:rPr kumimoji="1" lang="ja-JP" altLang="en-US"/>
+              <a:t>第 </a:t>
+            </a:r>
+            <a:r>
+              <a:rPr kumimoji="1" lang="en-US" altLang="ja-JP"/>
+              <a:t>5 </a:t>
+            </a:r>
+            <a:r>
+              <a:rPr kumimoji="1" lang="ja-JP" altLang="en-US"/>
+              <a:t>レベル</a:t>
+            </a:r>
+          </a:p>
+        </p:txBody>
+      </p:sp>
+      <p:sp>
+        <p:nvSpPr>
+          <p:cNvPr id="6" name="フッター プレースホルダー 5"/>
+          <p:cNvSpPr>
+            <a:spLocks noGrp="1"/>
+          </p:cNvSpPr>
+          <p:nvPr>
+            <p:ph type="ftr" sz="quarter" idx="4"/>
+          </p:nvPr>
+        </p:nvSpPr>
+        <p:spPr>
+          <a:xfrm>
+            <a:off x="0" y="8685213"/>
+            <a:ext cx="2971800" cy="458787"/>
+          </a:xfrm>
+          <a:prstGeom prst="rect">
+            <a:avLst/>
+          </a:prstGeom>
+        </p:spPr>
+        <p:txBody>
+          <a:bodyPr vert="horz" lIns="91440" tIns="45720" rIns="91440" bIns="45720" rtlCol="0" anchor="b"/>
+          <a:lstStyle>
+            <a:lvl1pPr algn="l">
+              <a:defRPr sz="1200"/>
+            </a:lvl1pPr>
+          </a:lstStyle>
+          <a:p>
+            <a:endParaRPr kumimoji="1" lang="ja-JP" altLang="en-US"/>
+          </a:p>
+        </p:txBody>
+      </p:sp>
+      <p:sp>
+        <p:nvSpPr>
+          <p:cNvPr id="7" name="スライド番号プレースホルダー 6"/>
+          <p:cNvSpPr>
+            <a:spLocks noGrp="1"/>
+          </p:cNvSpPr>
+          <p:nvPr>
+            <p:ph type="sldNum" sz="quarter" idx="5"/>
+          </p:nvPr>
+        </p:nvSpPr>
+        <p:spPr>
+          <a:xfrm>
+            <a:off x="3884613" y="8685213"/>
+            <a:ext cx="2971800" cy="458787"/>
+          </a:xfrm>
+          <a:prstGeom prst="rect">
+            <a:avLst/>
+          </a:prstGeom>
+        </p:spPr>
+        <p:txBody>
+          <a:bodyPr vert="horz" lIns="91440" tIns="45720" rIns="91440" bIns="45720" rtlCol="0" anchor="b"/>
+          <a:lstStyle>
+            <a:lvl1pPr algn="r">
+              <a:defRPr sz="1200"/>
+            </a:lvl1pPr>
+          </a:lstStyle>
+          <a:p>
+            <a:fld id="{EF726A1B-3681-482B-AB6D-4902C2351D7C}" type="slidenum">
+              <a:rPr kumimoji="1" lang="ja-JP" altLang="en-US" smtClean="0"/>
+              <a:t>‹#›</a:t>
+            </a:fld>
+            <a:endParaRPr kumimoji="1" lang="ja-JP" altLang="en-US"/>
+          </a:p>
+        </p:txBody>
+      </p:sp>
+    </p:spTree>
+    <p:extLst>
+      <p:ext uri="{BB962C8B-B14F-4D97-AF65-F5344CB8AC3E}">
+        <p14:creationId xmlns:p14="http://schemas.microsoft.com/office/powerpoint/2010/main" val="2798325032"/>
+      </p:ext>
+    </p:extLst>
+  </p:cSld>
+  <p:clrMap bg1="lt1" tx1="dk1" bg2="lt2" tx2="dk2" accent1="accent1" accent2="accent2" accent3="accent3" accent4="accent4" accent5="accent5" accent6="accent6" hlink="hlink" folHlink="folHlink"/>
+  <p:notesStyle>
+    <a:lvl1pPr marL="0" algn="l" defTabSz="914400" rtl="0" eaLnBrk="1" latinLnBrk="0" hangingPunct="1">
+      <a:defRPr kumimoji="1" sz="1200" kern="1200">
+        <a:solidFill>
+          <a:schemeClr val="tx1"/>
+        </a:solidFill>
+        <a:latin typeface="+mn-lt"/>
+        <a:ea typeface="+mn-ea"/>
+        <a:cs typeface="+mn-cs"/>
+      </a:defRPr>
+    </a:lvl1pPr>
+    <a:lvl2pPr marL="457200" algn="l" defTabSz="914400" rtl="0" eaLnBrk="1" latinLnBrk="0" hangingPunct="1">
+      <a:defRPr kumimoji="1" sz="1200" kern="1200">
+        <a:solidFill>
+          <a:schemeClr val="tx1"/>
+        </a:solidFill>
+        <a:latin typeface="+mn-lt"/>
+        <a:ea typeface="+mn-ea"/>
+        <a:cs typeface="+mn-cs"/>
+      </a:defRPr>
+    </a:lvl2pPr>
+    <a:lvl3pPr marL="914400" algn="l" defTabSz="914400" rtl="0" eaLnBrk="1" latinLnBrk="0" hangingPunct="1">
+      <a:defRPr kumimoji="1" sz="1200" kern="1200">
+        <a:solidFill>
+          <a:schemeClr val="tx1"/>
+        </a:solidFill>
+        <a:latin typeface="+mn-lt"/>
+        <a:ea typeface="+mn-ea"/>
+        <a:cs typeface="+mn-cs"/>
+      </a:defRPr>
+    </a:lvl3pPr>
+    <a:lvl4pPr marL="1371600" algn="l" defTabSz="914400" rtl="0" eaLnBrk="1" latinLnBrk="0" hangingPunct="1">
+      <a:defRPr kumimoji="1" sz="1200" kern="1200">
+        <a:solidFill>
+          <a:schemeClr val="tx1"/>
+        </a:solidFill>
+        <a:latin typeface="+mn-lt"/>
+        <a:ea typeface="+mn-ea"/>
+        <a:cs typeface="+mn-cs"/>
+      </a:defRPr>
+    </a:lvl4pPr>
+    <a:lvl5pPr marL="1828800" algn="l" defTabSz="914400" rtl="0" eaLnBrk="1" latinLnBrk="0" hangingPunct="1">
+      <a:defRPr kumimoji="1" sz="1200" kern="1200">
+        <a:solidFill>
+          <a:schemeClr val="tx1"/>
+        </a:solidFill>
+        <a:latin typeface="+mn-lt"/>
+        <a:ea typeface="+mn-ea"/>
+        <a:cs typeface="+mn-cs"/>
+      </a:defRPr>
+    </a:lvl5pPr>
+    <a:lvl6pPr marL="2286000" algn="l" defTabSz="914400" rtl="0" eaLnBrk="1" latinLnBrk="0" hangingPunct="1">
+      <a:defRPr kumimoji="1" sz="1200" kern="1200">
+        <a:solidFill>
+          <a:schemeClr val="tx1"/>
+        </a:solidFill>
+        <a:latin typeface="+mn-lt"/>
+        <a:ea typeface="+mn-ea"/>
+        <a:cs typeface="+mn-cs"/>
+      </a:defRPr>
+    </a:lvl6pPr>
+    <a:lvl7pPr marL="2743200" algn="l" defTabSz="914400" rtl="0" eaLnBrk="1" latinLnBrk="0" hangingPunct="1">
+      <a:defRPr kumimoji="1" sz="1200" kern="1200">
+        <a:solidFill>
+          <a:schemeClr val="tx1"/>
+        </a:solidFill>
+        <a:latin typeface="+mn-lt"/>
+        <a:ea typeface="+mn-ea"/>
+        <a:cs typeface="+mn-cs"/>
+      </a:defRPr>
+    </a:lvl7pPr>
+    <a:lvl8pPr marL="3200400" algn="l" defTabSz="914400" rtl="0" eaLnBrk="1" latinLnBrk="0" hangingPunct="1">
+      <a:defRPr kumimoji="1" sz="1200" kern="1200">
+        <a:solidFill>
+          <a:schemeClr val="tx1"/>
+        </a:solidFill>
+        <a:latin typeface="+mn-lt"/>
+        <a:ea typeface="+mn-ea"/>
+        <a:cs typeface="+mn-cs"/>
+      </a:defRPr>
+    </a:lvl8pPr>
+    <a:lvl9pPr marL="3657600" algn="l" defTabSz="914400" rtl="0" eaLnBrk="1" latinLnBrk="0" hangingPunct="1">
+      <a:defRPr kumimoji="1" sz="1200" kern="1200">
+        <a:solidFill>
+          <a:schemeClr val="tx1"/>
+        </a:solidFill>
+        <a:latin typeface="+mn-lt"/>
+        <a:ea typeface="+mn-ea"/>
+        <a:cs typeface="+mn-cs"/>
+      </a:defRPr>
+    </a:lvl9pPr>
+  </p:notesStyle>
+</p:notesMaster>
+</file>
+
+<file path=ppt/notesSlides/notesSlide1.xml><?xml version="1.0" encoding="utf-8"?>
+<p:notes xmlns:a="http://schemas.openxmlformats.org/drawingml/2006/main" xmlns:r="http://schemas.openxmlformats.org/officeDocument/2006/relationships" xmlns:p="http://schemas.openxmlformats.org/presentationml/2006/main">
+  <p:cSld>
+    <p:spTree>
+      <p:nvGrpSpPr>
+        <p:cNvPr id="1" name=""/>
+        <p:cNvGrpSpPr/>
+        <p:nvPr/>
+      </p:nvGrpSpPr>
+      <p:grpSpPr>
+        <a:xfrm>
+          <a:off x="0" y="0"/>
+          <a:ext cx="0" cy="0"/>
+          <a:chOff x="0" y="0"/>
+          <a:chExt cx="0" cy="0"/>
+        </a:xfrm>
+      </p:grpSpPr>
+      <p:sp>
+        <p:nvSpPr>
+          <p:cNvPr id="2" name="スライド イメージ プレースホルダー 1"/>
+          <p:cNvSpPr>
+            <a:spLocks noGrp="1" noRot="1" noChangeAspect="1"/>
+          </p:cNvSpPr>
+          <p:nvPr>
+            <p:ph type="sldImg"/>
+          </p:nvPr>
+        </p:nvSpPr>
+        <p:spPr/>
+      </p:sp>
+      <p:sp>
+        <p:nvSpPr>
+          <p:cNvPr id="3" name="ノート プレースホルダー 2"/>
+          <p:cNvSpPr>
+            <a:spLocks noGrp="1"/>
+          </p:cNvSpPr>
+          <p:nvPr>
+            <p:ph type="body" idx="1"/>
+          </p:nvPr>
+        </p:nvSpPr>
+        <p:spPr/>
+        <p:txBody>
+          <a:bodyPr/>
+          <a:lstStyle/>
+          <a:p>
+            <a:endParaRPr kumimoji="1" lang="ja-JP" altLang="en-US" dirty="0"/>
+          </a:p>
+        </p:txBody>
+      </p:sp>
+      <p:sp>
+        <p:nvSpPr>
+          <p:cNvPr id="4" name="スライド番号プレースホルダー 3"/>
+          <p:cNvSpPr>
+            <a:spLocks noGrp="1"/>
+          </p:cNvSpPr>
+          <p:nvPr>
+            <p:ph type="sldNum" sz="quarter" idx="5"/>
+          </p:nvPr>
+        </p:nvSpPr>
+        <p:spPr/>
+        <p:txBody>
+          <a:bodyPr/>
+          <a:lstStyle/>
+          <a:p>
+            <a:fld id="{EF726A1B-3681-482B-AB6D-4902C2351D7C}" type="slidenum">
+              <a:rPr kumimoji="1" lang="ja-JP" altLang="en-US" smtClean="0"/>
+              <a:t>13</a:t>
+            </a:fld>
+            <a:endParaRPr kumimoji="1" lang="ja-JP" altLang="en-US"/>
+          </a:p>
+        </p:txBody>
+      </p:sp>
+    </p:spTree>
+    <p:extLst>
+      <p:ext uri="{BB962C8B-B14F-4D97-AF65-F5344CB8AC3E}">
+        <p14:creationId xmlns:p14="http://schemas.microsoft.com/office/powerpoint/2010/main" val="3464478598"/>
+      </p:ext>
+    </p:extLst>
+  </p:cSld>
+  <p:clrMapOvr>
+    <a:masterClrMapping/>
+  </p:clrMapOvr>
+</p:notes>
 </file>
 
 <file path=ppt/slideLayouts/slideLayout1.xml><?xml version="1.0" encoding="utf-8"?>
@@ -159,10 +680,9 @@
           <a:lstStyle/>
           <a:p>
             <a:r>
-              <a:rPr lang="en-US" smtClean="0"/>
+              <a:rPr lang="en-US"/>
               <a:t>Click to edit Master title style</a:t>
             </a:r>
-            <a:endParaRPr lang="en-US"/>
           </a:p>
         </p:txBody>
       </p:sp>
@@ -278,10 +798,9 @@
           </a:lstStyle>
           <a:p>
             <a:r>
-              <a:rPr lang="en-US" smtClean="0"/>
+              <a:rPr lang="en-US"/>
               <a:t>Click to edit Master subtitle style</a:t>
             </a:r>
-            <a:endParaRPr lang="en-US"/>
           </a:p>
         </p:txBody>
       </p:sp>
@@ -302,7 +821,7 @@
           <a:p>
             <a:fld id="{5BCAD085-E8A6-8845-BD4E-CB4CCA059FC4}" type="datetimeFigureOut">
               <a:rPr lang="en-US" smtClean="0"/>
-              <a:t>1/27/13</a:t>
+              <a:t>4/22/2026</a:t>
             </a:fld>
             <a:endParaRPr lang="en-US"/>
           </a:p>
@@ -396,10 +915,9 @@
           <a:lstStyle/>
           <a:p>
             <a:r>
-              <a:rPr lang="en-US" smtClean="0"/>
+              <a:rPr lang="en-US"/>
               <a:t>Click to edit Master title style</a:t>
             </a:r>
-            <a:endParaRPr lang="en-US"/>
           </a:p>
         </p:txBody>
       </p:sp>
@@ -420,38 +938,37 @@
           <a:p>
             <a:pPr lvl="0"/>
             <a:r>
-              <a:rPr lang="en-US" smtClean="0"/>
+              <a:rPr lang="en-US"/>
               <a:t>Click to edit Master text styles</a:t>
             </a:r>
           </a:p>
           <a:p>
             <a:pPr lvl="1"/>
             <a:r>
-              <a:rPr lang="en-US" smtClean="0"/>
+              <a:rPr lang="en-US"/>
               <a:t>Second level</a:t>
             </a:r>
           </a:p>
           <a:p>
             <a:pPr lvl="2"/>
             <a:r>
-              <a:rPr lang="en-US" smtClean="0"/>
+              <a:rPr lang="en-US"/>
               <a:t>Third level</a:t>
             </a:r>
           </a:p>
           <a:p>
             <a:pPr lvl="3"/>
             <a:r>
-              <a:rPr lang="en-US" smtClean="0"/>
+              <a:rPr lang="en-US"/>
               <a:t>Fourth level</a:t>
             </a:r>
           </a:p>
           <a:p>
             <a:pPr lvl="4"/>
             <a:r>
-              <a:rPr lang="en-US" smtClean="0"/>
+              <a:rPr lang="en-US"/>
               <a:t>Fifth level</a:t>
             </a:r>
-            <a:endParaRPr lang="en-US"/>
           </a:p>
         </p:txBody>
       </p:sp>
@@ -472,7 +989,7 @@
           <a:p>
             <a:fld id="{5BCAD085-E8A6-8845-BD4E-CB4CCA059FC4}" type="datetimeFigureOut">
               <a:rPr lang="en-US" smtClean="0"/>
-              <a:t>1/27/13</a:t>
+              <a:t>4/22/2026</a:t>
             </a:fld>
             <a:endParaRPr lang="en-US"/>
           </a:p>
@@ -571,10 +1088,9 @@
           <a:lstStyle/>
           <a:p>
             <a:r>
-              <a:rPr lang="en-US" smtClean="0"/>
+              <a:rPr lang="en-US"/>
               <a:t>Click to edit Master title style</a:t>
             </a:r>
-            <a:endParaRPr lang="en-US"/>
           </a:p>
         </p:txBody>
       </p:sp>
@@ -600,38 +1116,37 @@
           <a:p>
             <a:pPr lvl="0"/>
             <a:r>
-              <a:rPr lang="en-US" smtClean="0"/>
+              <a:rPr lang="en-US"/>
               <a:t>Click to edit Master text styles</a:t>
             </a:r>
           </a:p>
           <a:p>
             <a:pPr lvl="1"/>
             <a:r>
-              <a:rPr lang="en-US" smtClean="0"/>
+              <a:rPr lang="en-US"/>
               <a:t>Second level</a:t>
             </a:r>
           </a:p>
           <a:p>
             <a:pPr lvl="2"/>
             <a:r>
-              <a:rPr lang="en-US" smtClean="0"/>
+              <a:rPr lang="en-US"/>
               <a:t>Third level</a:t>
             </a:r>
           </a:p>
           <a:p>
             <a:pPr lvl="3"/>
             <a:r>
-              <a:rPr lang="en-US" smtClean="0"/>
+              <a:rPr lang="en-US"/>
               <a:t>Fourth level</a:t>
             </a:r>
           </a:p>
           <a:p>
             <a:pPr lvl="4"/>
             <a:r>
-              <a:rPr lang="en-US" smtClean="0"/>
+              <a:rPr lang="en-US"/>
               <a:t>Fifth level</a:t>
             </a:r>
-            <a:endParaRPr lang="en-US"/>
           </a:p>
         </p:txBody>
       </p:sp>
@@ -652,7 +1167,7 @@
           <a:p>
             <a:fld id="{5BCAD085-E8A6-8845-BD4E-CB4CCA059FC4}" type="datetimeFigureOut">
               <a:rPr lang="en-US" smtClean="0"/>
-              <a:t>1/27/13</a:t>
+              <a:t>4/22/2026</a:t>
             </a:fld>
             <a:endParaRPr lang="en-US"/>
           </a:p>
@@ -746,10 +1261,9 @@
           <a:lstStyle/>
           <a:p>
             <a:r>
-              <a:rPr lang="en-US" smtClean="0"/>
+              <a:rPr lang="en-US"/>
               <a:t>Click to edit Master title style</a:t>
             </a:r>
-            <a:endParaRPr lang="en-US"/>
           </a:p>
         </p:txBody>
       </p:sp>
@@ -770,38 +1284,37 @@
           <a:p>
             <a:pPr lvl="0"/>
             <a:r>
-              <a:rPr lang="en-US" smtClean="0"/>
+              <a:rPr lang="en-US"/>
               <a:t>Click to edit Master text styles</a:t>
             </a:r>
           </a:p>
           <a:p>
             <a:pPr lvl="1"/>
             <a:r>
-              <a:rPr lang="en-US" smtClean="0"/>
+              <a:rPr lang="en-US"/>
               <a:t>Second level</a:t>
             </a:r>
           </a:p>
           <a:p>
             <a:pPr lvl="2"/>
             <a:r>
-              <a:rPr lang="en-US" smtClean="0"/>
+              <a:rPr lang="en-US"/>
               <a:t>Third level</a:t>
             </a:r>
           </a:p>
           <a:p>
             <a:pPr lvl="3"/>
             <a:r>
-              <a:rPr lang="en-US" smtClean="0"/>
+              <a:rPr lang="en-US"/>
               <a:t>Fourth level</a:t>
             </a:r>
           </a:p>
           <a:p>
             <a:pPr lvl="4"/>
             <a:r>
-              <a:rPr lang="en-US" smtClean="0"/>
+              <a:rPr lang="en-US"/>
               <a:t>Fifth level</a:t>
             </a:r>
-            <a:endParaRPr lang="en-US"/>
           </a:p>
         </p:txBody>
       </p:sp>
@@ -822,7 +1335,7 @@
           <a:p>
             <a:fld id="{5BCAD085-E8A6-8845-BD4E-CB4CCA059FC4}" type="datetimeFigureOut">
               <a:rPr lang="en-US" smtClean="0"/>
-              <a:t>1/27/13</a:t>
+              <a:t>4/22/2026</a:t>
             </a:fld>
             <a:endParaRPr lang="en-US"/>
           </a:p>
@@ -925,10 +1438,9 @@
           </a:lstStyle>
           <a:p>
             <a:r>
-              <a:rPr lang="en-US" smtClean="0"/>
+              <a:rPr lang="en-US"/>
               <a:t>Click to edit Master title style</a:t>
             </a:r>
-            <a:endParaRPr lang="en-US"/>
           </a:p>
         </p:txBody>
       </p:sp>
@@ -1045,7 +1557,7 @@
           <a:p>
             <a:pPr lvl="0"/>
             <a:r>
-              <a:rPr lang="en-US" smtClean="0"/>
+              <a:rPr lang="en-US"/>
               <a:t>Click to edit Master text styles</a:t>
             </a:r>
           </a:p>
@@ -1068,7 +1580,7 @@
           <a:p>
             <a:fld id="{5BCAD085-E8A6-8845-BD4E-CB4CCA059FC4}" type="datetimeFigureOut">
               <a:rPr lang="en-US" smtClean="0"/>
-              <a:t>1/27/13</a:t>
+              <a:t>4/22/2026</a:t>
             </a:fld>
             <a:endParaRPr lang="en-US"/>
           </a:p>
@@ -1162,10 +1674,9 @@
           <a:lstStyle/>
           <a:p>
             <a:r>
-              <a:rPr lang="en-US" smtClean="0"/>
+              <a:rPr lang="en-US"/>
               <a:t>Click to edit Master title style</a:t>
             </a:r>
-            <a:endParaRPr lang="en-US"/>
           </a:p>
         </p:txBody>
       </p:sp>
@@ -1219,38 +1730,37 @@
           <a:p>
             <a:pPr lvl="0"/>
             <a:r>
-              <a:rPr lang="en-US" smtClean="0"/>
+              <a:rPr lang="en-US"/>
               <a:t>Click to edit Master text styles</a:t>
             </a:r>
           </a:p>
           <a:p>
             <a:pPr lvl="1"/>
             <a:r>
-              <a:rPr lang="en-US" smtClean="0"/>
+              <a:rPr lang="en-US"/>
               <a:t>Second level</a:t>
             </a:r>
           </a:p>
           <a:p>
             <a:pPr lvl="2"/>
             <a:r>
-              <a:rPr lang="en-US" smtClean="0"/>
+              <a:rPr lang="en-US"/>
               <a:t>Third level</a:t>
             </a:r>
           </a:p>
           <a:p>
             <a:pPr lvl="3"/>
             <a:r>
-              <a:rPr lang="en-US" smtClean="0"/>
+              <a:rPr lang="en-US"/>
               <a:t>Fourth level</a:t>
             </a:r>
           </a:p>
           <a:p>
             <a:pPr lvl="4"/>
             <a:r>
-              <a:rPr lang="en-US" smtClean="0"/>
+              <a:rPr lang="en-US"/>
               <a:t>Fifth level</a:t>
             </a:r>
-            <a:endParaRPr lang="en-US"/>
           </a:p>
         </p:txBody>
       </p:sp>
@@ -1304,38 +1814,37 @@
           <a:p>
             <a:pPr lvl="0"/>
             <a:r>
-              <a:rPr lang="en-US" smtClean="0"/>
+              <a:rPr lang="en-US"/>
               <a:t>Click to edit Master text styles</a:t>
             </a:r>
           </a:p>
           <a:p>
             <a:pPr lvl="1"/>
             <a:r>
-              <a:rPr lang="en-US" smtClean="0"/>
+              <a:rPr lang="en-US"/>
               <a:t>Second level</a:t>
             </a:r>
           </a:p>
           <a:p>
             <a:pPr lvl="2"/>
             <a:r>
-              <a:rPr lang="en-US" smtClean="0"/>
+              <a:rPr lang="en-US"/>
               <a:t>Third level</a:t>
             </a:r>
           </a:p>
           <a:p>
             <a:pPr lvl="3"/>
             <a:r>
-              <a:rPr lang="en-US" smtClean="0"/>
+              <a:rPr lang="en-US"/>
               <a:t>Fourth level</a:t>
             </a:r>
           </a:p>
           <a:p>
             <a:pPr lvl="4"/>
             <a:r>
-              <a:rPr lang="en-US" smtClean="0"/>
+              <a:rPr lang="en-US"/>
               <a:t>Fifth level</a:t>
             </a:r>
-            <a:endParaRPr lang="en-US"/>
           </a:p>
         </p:txBody>
       </p:sp>
@@ -1356,7 +1865,7 @@
           <a:p>
             <a:fld id="{5BCAD085-E8A6-8845-BD4E-CB4CCA059FC4}" type="datetimeFigureOut">
               <a:rPr lang="en-US" smtClean="0"/>
-              <a:t>1/27/13</a:t>
+              <a:t>4/22/2026</a:t>
             </a:fld>
             <a:endParaRPr lang="en-US"/>
           </a:p>
@@ -1454,10 +1963,9 @@
           </a:lstStyle>
           <a:p>
             <a:r>
-              <a:rPr lang="en-US" smtClean="0"/>
+              <a:rPr lang="en-US"/>
               <a:t>Click to edit Master title style</a:t>
             </a:r>
-            <a:endParaRPr lang="en-US"/>
           </a:p>
         </p:txBody>
       </p:sp>
@@ -1520,7 +2028,7 @@
           <a:p>
             <a:pPr lvl="0"/>
             <a:r>
-              <a:rPr lang="en-US" smtClean="0"/>
+              <a:rPr lang="en-US"/>
               <a:t>Click to edit Master text styles</a:t>
             </a:r>
           </a:p>
@@ -1576,38 +2084,37 @@
           <a:p>
             <a:pPr lvl="0"/>
             <a:r>
-              <a:rPr lang="en-US" smtClean="0"/>
+              <a:rPr lang="en-US"/>
               <a:t>Click to edit Master text styles</a:t>
             </a:r>
           </a:p>
           <a:p>
             <a:pPr lvl="1"/>
             <a:r>
-              <a:rPr lang="en-US" smtClean="0"/>
+              <a:rPr lang="en-US"/>
               <a:t>Second level</a:t>
             </a:r>
           </a:p>
           <a:p>
             <a:pPr lvl="2"/>
             <a:r>
-              <a:rPr lang="en-US" smtClean="0"/>
+              <a:rPr lang="en-US"/>
               <a:t>Third level</a:t>
             </a:r>
           </a:p>
           <a:p>
             <a:pPr lvl="3"/>
             <a:r>
-              <a:rPr lang="en-US" smtClean="0"/>
+              <a:rPr lang="en-US"/>
               <a:t>Fourth level</a:t>
             </a:r>
           </a:p>
           <a:p>
             <a:pPr lvl="4"/>
             <a:r>
-              <a:rPr lang="en-US" smtClean="0"/>
+              <a:rPr lang="en-US"/>
               <a:t>Fifth level</a:t>
             </a:r>
-            <a:endParaRPr lang="en-US"/>
           </a:p>
         </p:txBody>
       </p:sp>
@@ -1670,7 +2177,7 @@
           <a:p>
             <a:pPr lvl="0"/>
             <a:r>
-              <a:rPr lang="en-US" smtClean="0"/>
+              <a:rPr lang="en-US"/>
               <a:t>Click to edit Master text styles</a:t>
             </a:r>
           </a:p>
@@ -1726,38 +2233,37 @@
           <a:p>
             <a:pPr lvl="0"/>
             <a:r>
-              <a:rPr lang="en-US" smtClean="0"/>
+              <a:rPr lang="en-US"/>
               <a:t>Click to edit Master text styles</a:t>
             </a:r>
           </a:p>
           <a:p>
             <a:pPr lvl="1"/>
             <a:r>
-              <a:rPr lang="en-US" smtClean="0"/>
+              <a:rPr lang="en-US"/>
               <a:t>Second level</a:t>
             </a:r>
           </a:p>
           <a:p>
             <a:pPr lvl="2"/>
             <a:r>
-              <a:rPr lang="en-US" smtClean="0"/>
+              <a:rPr lang="en-US"/>
               <a:t>Third level</a:t>
             </a:r>
           </a:p>
           <a:p>
             <a:pPr lvl="3"/>
             <a:r>
-              <a:rPr lang="en-US" smtClean="0"/>
+              <a:rPr lang="en-US"/>
               <a:t>Fourth level</a:t>
             </a:r>
           </a:p>
           <a:p>
             <a:pPr lvl="4"/>
             <a:r>
-              <a:rPr lang="en-US" smtClean="0"/>
+              <a:rPr lang="en-US"/>
               <a:t>Fifth level</a:t>
             </a:r>
-            <a:endParaRPr lang="en-US"/>
           </a:p>
         </p:txBody>
       </p:sp>
@@ -1778,7 +2284,7 @@
           <a:p>
             <a:fld id="{5BCAD085-E8A6-8845-BD4E-CB4CCA059FC4}" type="datetimeFigureOut">
               <a:rPr lang="en-US" smtClean="0"/>
-              <a:t>1/27/13</a:t>
+              <a:t>4/22/2026</a:t>
             </a:fld>
             <a:endParaRPr lang="en-US"/>
           </a:p>
@@ -1872,10 +2378,9 @@
           <a:lstStyle/>
           <a:p>
             <a:r>
-              <a:rPr lang="en-US" smtClean="0"/>
+              <a:rPr lang="en-US"/>
               <a:t>Click to edit Master title style</a:t>
             </a:r>
-            <a:endParaRPr lang="en-US"/>
           </a:p>
         </p:txBody>
       </p:sp>
@@ -1896,7 +2401,7 @@
           <a:p>
             <a:fld id="{5BCAD085-E8A6-8845-BD4E-CB4CCA059FC4}" type="datetimeFigureOut">
               <a:rPr lang="en-US" smtClean="0"/>
-              <a:t>1/27/13</a:t>
+              <a:t>4/22/2026</a:t>
             </a:fld>
             <a:endParaRPr lang="en-US"/>
           </a:p>
@@ -1991,7 +2496,7 @@
           <a:p>
             <a:fld id="{5BCAD085-E8A6-8845-BD4E-CB4CCA059FC4}" type="datetimeFigureOut">
               <a:rPr lang="en-US" smtClean="0"/>
-              <a:t>1/27/13</a:t>
+              <a:t>4/22/2026</a:t>
             </a:fld>
             <a:endParaRPr lang="en-US"/>
           </a:p>
@@ -2094,10 +2599,9 @@
           </a:lstStyle>
           <a:p>
             <a:r>
-              <a:rPr lang="en-US" smtClean="0"/>
+              <a:rPr lang="en-US"/>
               <a:t>Click to edit Master title style</a:t>
             </a:r>
-            <a:endParaRPr lang="en-US"/>
           </a:p>
         </p:txBody>
       </p:sp>
@@ -2151,38 +2655,37 @@
           <a:p>
             <a:pPr lvl="0"/>
             <a:r>
-              <a:rPr lang="en-US" smtClean="0"/>
+              <a:rPr lang="en-US"/>
               <a:t>Click to edit Master text styles</a:t>
             </a:r>
           </a:p>
           <a:p>
             <a:pPr lvl="1"/>
             <a:r>
-              <a:rPr lang="en-US" smtClean="0"/>
+              <a:rPr lang="en-US"/>
               <a:t>Second level</a:t>
             </a:r>
           </a:p>
           <a:p>
             <a:pPr lvl="2"/>
             <a:r>
-              <a:rPr lang="en-US" smtClean="0"/>
+              <a:rPr lang="en-US"/>
               <a:t>Third level</a:t>
             </a:r>
           </a:p>
           <a:p>
             <a:pPr lvl="3"/>
             <a:r>
-              <a:rPr lang="en-US" smtClean="0"/>
+              <a:rPr lang="en-US"/>
               <a:t>Fourth level</a:t>
             </a:r>
           </a:p>
           <a:p>
             <a:pPr lvl="4"/>
             <a:r>
-              <a:rPr lang="en-US" smtClean="0"/>
+              <a:rPr lang="en-US"/>
               <a:t>Fifth level</a:t>
             </a:r>
-            <a:endParaRPr lang="en-US"/>
           </a:p>
         </p:txBody>
       </p:sp>
@@ -2245,7 +2748,7 @@
           <a:p>
             <a:pPr lvl="0"/>
             <a:r>
-              <a:rPr lang="en-US" smtClean="0"/>
+              <a:rPr lang="en-US"/>
               <a:t>Click to edit Master text styles</a:t>
             </a:r>
           </a:p>
@@ -2268,7 +2771,7 @@
           <a:p>
             <a:fld id="{5BCAD085-E8A6-8845-BD4E-CB4CCA059FC4}" type="datetimeFigureOut">
               <a:rPr lang="en-US" smtClean="0"/>
-              <a:t>1/27/13</a:t>
+              <a:t>4/22/2026</a:t>
             </a:fld>
             <a:endParaRPr lang="en-US"/>
           </a:p>
@@ -2371,10 +2874,9 @@
           </a:lstStyle>
           <a:p>
             <a:r>
-              <a:rPr lang="en-US" smtClean="0"/>
+              <a:rPr lang="en-US"/>
               <a:t>Click to edit Master title style</a:t>
             </a:r>
-            <a:endParaRPr lang="en-US"/>
           </a:p>
         </p:txBody>
       </p:sp>
@@ -2498,7 +3000,7 @@
           <a:p>
             <a:pPr lvl="0"/>
             <a:r>
-              <a:rPr lang="en-US" smtClean="0"/>
+              <a:rPr lang="en-US"/>
               <a:t>Click to edit Master text styles</a:t>
             </a:r>
           </a:p>
@@ -2521,7 +3023,7 @@
           <a:p>
             <a:fld id="{5BCAD085-E8A6-8845-BD4E-CB4CCA059FC4}" type="datetimeFigureOut">
               <a:rPr lang="en-US" smtClean="0"/>
-              <a:t>1/27/13</a:t>
+              <a:t>4/22/2026</a:t>
             </a:fld>
             <a:endParaRPr lang="en-US"/>
           </a:p>
@@ -2630,10 +3132,9 @@
           <a:lstStyle/>
           <a:p>
             <a:r>
-              <a:rPr lang="en-US" smtClean="0"/>
+              <a:rPr lang="en-US"/>
               <a:t>Click to edit Master title style</a:t>
             </a:r>
-            <a:endParaRPr lang="en-US"/>
           </a:p>
         </p:txBody>
       </p:sp>
@@ -2664,38 +3165,37 @@
           <a:p>
             <a:pPr lvl="0"/>
             <a:r>
-              <a:rPr lang="en-US" smtClean="0"/>
+              <a:rPr lang="en-US"/>
               <a:t>Click to edit Master text styles</a:t>
             </a:r>
           </a:p>
           <a:p>
             <a:pPr lvl="1"/>
             <a:r>
-              <a:rPr lang="en-US" smtClean="0"/>
+              <a:rPr lang="en-US"/>
               <a:t>Second level</a:t>
             </a:r>
           </a:p>
           <a:p>
             <a:pPr lvl="2"/>
             <a:r>
-              <a:rPr lang="en-US" smtClean="0"/>
+              <a:rPr lang="en-US"/>
               <a:t>Third level</a:t>
             </a:r>
           </a:p>
           <a:p>
             <a:pPr lvl="3"/>
             <a:r>
-              <a:rPr lang="en-US" smtClean="0"/>
+              <a:rPr lang="en-US"/>
               <a:t>Fourth level</a:t>
             </a:r>
           </a:p>
           <a:p>
             <a:pPr lvl="4"/>
             <a:r>
-              <a:rPr lang="en-US" smtClean="0"/>
+              <a:rPr lang="en-US"/>
               <a:t>Fifth level</a:t>
             </a:r>
-            <a:endParaRPr lang="en-US"/>
           </a:p>
         </p:txBody>
       </p:sp>
@@ -2734,7 +3234,7 @@
           <a:p>
             <a:fld id="{5BCAD085-E8A6-8845-BD4E-CB4CCA059FC4}" type="datetimeFigureOut">
               <a:rPr lang="en-US" smtClean="0"/>
-              <a:t>1/27/13</a:t>
+              <a:t>4/22/2026</a:t>
             </a:fld>
             <a:endParaRPr lang="en-US"/>
           </a:p>
@@ -3093,7 +3593,7 @@
 </file>
 
 <file path=ppt/slides/slide1.xml><?xml version="1.0" encoding="utf-8"?>
-<p:sld xmlns:a="http://schemas.openxmlformats.org/drawingml/2006/main" xmlns:p="http://schemas.openxmlformats.org/presentationml/2006/main" xmlns:r="http://schemas.openxmlformats.org/officeDocument/2006/relationships">
+<p:sld xmlns:a="http://schemas.openxmlformats.org/drawingml/2006/main" xmlns:r="http://schemas.openxmlformats.org/officeDocument/2006/relationships" xmlns:p="http://schemas.openxmlformats.org/presentationml/2006/main">
   <p:cSld>
     <p:spTree>
       <p:nvGrpSpPr>
@@ -3101,7 +3601,14 @@
         <p:cNvGrpSpPr/>
         <p:nvPr/>
       </p:nvGrpSpPr>
-      <p:grpSpPr/>
+      <p:grpSpPr>
+        <a:xfrm>
+          <a:off x="0" y="0"/>
+          <a:ext cx="0" cy="0"/>
+          <a:chOff x="0" y="0"/>
+          <a:chExt cx="0" cy="0"/>
+        </a:xfrm>
+      </p:grpSpPr>
       <p:sp>
         <p:nvSpPr>
           <p:cNvPr id="2" name="Rectangle 1"/>
@@ -3142,6 +3649,7 @@
           <a:lstStyle/>
           <a:p>
             <a:pPr algn="ctr"/>
+            <a:endParaRPr/>
           </a:p>
         </p:txBody>
       </p:sp>
@@ -3185,6 +3693,7 @@
           <a:lstStyle/>
           <a:p>
             <a:pPr algn="ctr"/>
+            <a:endParaRPr/>
           </a:p>
         </p:txBody>
       </p:sp>
@@ -3296,6 +3805,7 @@
           <a:lstStyle/>
           <a:p>
             <a:pPr algn="ctr"/>
+            <a:endParaRPr/>
           </a:p>
         </p:txBody>
       </p:sp>
@@ -3376,7 +3886,7 @@
 </file>
 
 <file path=ppt/slides/slide10.xml><?xml version="1.0" encoding="utf-8"?>
-<p:sld xmlns:a="http://schemas.openxmlformats.org/drawingml/2006/main" xmlns:p="http://schemas.openxmlformats.org/presentationml/2006/main" xmlns:r="http://schemas.openxmlformats.org/officeDocument/2006/relationships">
+<p:sld xmlns:a="http://schemas.openxmlformats.org/drawingml/2006/main" xmlns:r="http://schemas.openxmlformats.org/officeDocument/2006/relationships" xmlns:p="http://schemas.openxmlformats.org/presentationml/2006/main">
   <p:cSld>
     <p:spTree>
       <p:nvGrpSpPr>
@@ -3384,7 +3894,14 @@
         <p:cNvGrpSpPr/>
         <p:nvPr/>
       </p:nvGrpSpPr>
-      <p:grpSpPr/>
+      <p:grpSpPr>
+        <a:xfrm>
+          <a:off x="0" y="0"/>
+          <a:ext cx="0" cy="0"/>
+          <a:chOff x="0" y="0"/>
+          <a:chExt cx="0" cy="0"/>
+        </a:xfrm>
+      </p:grpSpPr>
       <p:sp>
         <p:nvSpPr>
           <p:cNvPr id="2" name="Rectangle 1"/>
@@ -3425,6 +3942,7 @@
           <a:lstStyle/>
           <a:p>
             <a:pPr algn="ctr"/>
+            <a:endParaRPr/>
           </a:p>
         </p:txBody>
       </p:sp>
@@ -3468,6 +3986,7 @@
           <a:lstStyle/>
           <a:p>
             <a:pPr algn="ctr"/>
+            <a:endParaRPr/>
           </a:p>
         </p:txBody>
       </p:sp>
@@ -3545,6 +4064,7 @@
           <a:lstStyle/>
           <a:p>
             <a:pPr algn="ctr"/>
+            <a:endParaRPr/>
           </a:p>
         </p:txBody>
       </p:sp>
@@ -3656,6 +4176,7 @@
           <a:lstStyle/>
           <a:p>
             <a:pPr algn="ctr"/>
+            <a:endParaRPr/>
           </a:p>
         </p:txBody>
       </p:sp>
@@ -3733,6 +4254,7 @@
           <a:lstStyle/>
           <a:p>
             <a:pPr algn="ctr"/>
+            <a:endParaRPr/>
           </a:p>
         </p:txBody>
       </p:sp>
@@ -3810,6 +4332,7 @@
           <a:lstStyle/>
           <a:p>
             <a:pPr algn="ctr"/>
+            <a:endParaRPr/>
           </a:p>
         </p:txBody>
       </p:sp>
@@ -3890,7 +4413,7 @@
 </file>
 
 <file path=ppt/slides/slide11.xml><?xml version="1.0" encoding="utf-8"?>
-<p:sld xmlns:a="http://schemas.openxmlformats.org/drawingml/2006/main" xmlns:p="http://schemas.openxmlformats.org/presentationml/2006/main" xmlns:r="http://schemas.openxmlformats.org/officeDocument/2006/relationships">
+<p:sld xmlns:a="http://schemas.openxmlformats.org/drawingml/2006/main" xmlns:r="http://schemas.openxmlformats.org/officeDocument/2006/relationships" xmlns:p="http://schemas.openxmlformats.org/presentationml/2006/main">
   <p:cSld>
     <p:spTree>
       <p:nvGrpSpPr>
@@ -3898,7 +4421,14 @@
         <p:cNvGrpSpPr/>
         <p:nvPr/>
       </p:nvGrpSpPr>
-      <p:grpSpPr/>
+      <p:grpSpPr>
+        <a:xfrm>
+          <a:off x="0" y="0"/>
+          <a:ext cx="0" cy="0"/>
+          <a:chOff x="0" y="0"/>
+          <a:chExt cx="0" cy="0"/>
+        </a:xfrm>
+      </p:grpSpPr>
       <p:sp>
         <p:nvSpPr>
           <p:cNvPr id="2" name="Rectangle 1"/>
@@ -3939,6 +4469,7 @@
           <a:lstStyle/>
           <a:p>
             <a:pPr algn="ctr"/>
+            <a:endParaRPr/>
           </a:p>
         </p:txBody>
       </p:sp>
@@ -3982,6 +4513,7 @@
           <a:lstStyle/>
           <a:p>
             <a:pPr algn="ctr"/>
+            <a:endParaRPr/>
           </a:p>
         </p:txBody>
       </p:sp>
@@ -4059,6 +4591,7 @@
           <a:lstStyle/>
           <a:p>
             <a:pPr algn="ctr"/>
+            <a:endParaRPr/>
           </a:p>
         </p:txBody>
       </p:sp>
@@ -4136,6 +4669,7 @@
           <a:lstStyle/>
           <a:p>
             <a:pPr algn="ctr"/>
+            <a:endParaRPr/>
           </a:p>
         </p:txBody>
       </p:sp>
@@ -4179,6 +4713,7 @@
           <a:lstStyle/>
           <a:p>
             <a:pPr algn="ctr"/>
+            <a:endParaRPr/>
           </a:p>
         </p:txBody>
       </p:sp>
@@ -4290,6 +4825,7 @@
           <a:lstStyle/>
           <a:p>
             <a:pPr algn="ctr"/>
+            <a:endParaRPr/>
           </a:p>
         </p:txBody>
       </p:sp>
@@ -4333,6 +4869,7 @@
           <a:lstStyle/>
           <a:p>
             <a:pPr algn="ctr"/>
+            <a:endParaRPr/>
           </a:p>
         </p:txBody>
       </p:sp>
@@ -4444,6 +4981,7 @@
           <a:lstStyle/>
           <a:p>
             <a:pPr algn="ctr"/>
+            <a:endParaRPr/>
           </a:p>
         </p:txBody>
       </p:sp>
@@ -4487,6 +5025,7 @@
           <a:lstStyle/>
           <a:p>
             <a:pPr algn="ctr"/>
+            <a:endParaRPr/>
           </a:p>
         </p:txBody>
       </p:sp>
@@ -4598,6 +5137,7 @@
           <a:lstStyle/>
           <a:p>
             <a:pPr algn="ctr"/>
+            <a:endParaRPr/>
           </a:p>
         </p:txBody>
       </p:sp>
@@ -4641,6 +5181,7 @@
           <a:lstStyle/>
           <a:p>
             <a:pPr algn="ctr"/>
+            <a:endParaRPr/>
           </a:p>
         </p:txBody>
       </p:sp>
@@ -4752,6 +5293,7 @@
           <a:lstStyle/>
           <a:p>
             <a:pPr algn="ctr"/>
+            <a:endParaRPr/>
           </a:p>
         </p:txBody>
       </p:sp>
@@ -4798,7 +5340,7 @@
 </file>
 
 <file path=ppt/slides/slide12.xml><?xml version="1.0" encoding="utf-8"?>
-<p:sld xmlns:a="http://schemas.openxmlformats.org/drawingml/2006/main" xmlns:p="http://schemas.openxmlformats.org/presentationml/2006/main" xmlns:r="http://schemas.openxmlformats.org/officeDocument/2006/relationships">
+<p:sld xmlns:a="http://schemas.openxmlformats.org/drawingml/2006/main" xmlns:r="http://schemas.openxmlformats.org/officeDocument/2006/relationships" xmlns:p="http://schemas.openxmlformats.org/presentationml/2006/main">
   <p:cSld>
     <p:spTree>
       <p:nvGrpSpPr>
@@ -4806,7 +5348,14 @@
         <p:cNvGrpSpPr/>
         <p:nvPr/>
       </p:nvGrpSpPr>
-      <p:grpSpPr/>
+      <p:grpSpPr>
+        <a:xfrm>
+          <a:off x="0" y="0"/>
+          <a:ext cx="0" cy="0"/>
+          <a:chOff x="0" y="0"/>
+          <a:chExt cx="0" cy="0"/>
+        </a:xfrm>
+      </p:grpSpPr>
       <p:sp>
         <p:nvSpPr>
           <p:cNvPr id="2" name="Rectangle 1"/>
@@ -4847,6 +5396,7 @@
           <a:lstStyle/>
           <a:p>
             <a:pPr algn="ctr"/>
+            <a:endParaRPr/>
           </a:p>
         </p:txBody>
       </p:sp>
@@ -4890,6 +5440,7 @@
           <a:lstStyle/>
           <a:p>
             <a:pPr algn="ctr"/>
+            <a:endParaRPr/>
           </a:p>
         </p:txBody>
       </p:sp>
@@ -4967,6 +5518,7 @@
           <a:lstStyle/>
           <a:p>
             <a:pPr algn="ctr"/>
+            <a:endParaRPr/>
           </a:p>
         </p:txBody>
       </p:sp>
@@ -5044,6 +5596,7 @@
           <a:lstStyle/>
           <a:p>
             <a:pPr algn="ctr"/>
+            <a:endParaRPr/>
           </a:p>
         </p:txBody>
       </p:sp>
@@ -5121,6 +5674,7 @@
           <a:lstStyle/>
           <a:p>
             <a:pPr algn="ctr"/>
+            <a:endParaRPr/>
           </a:p>
         </p:txBody>
       </p:sp>
@@ -5232,6 +5786,7 @@
           <a:lstStyle/>
           <a:p>
             <a:pPr algn="ctr"/>
+            <a:endParaRPr/>
           </a:p>
         </p:txBody>
       </p:sp>
@@ -5343,6 +5898,7 @@
           <a:lstStyle/>
           <a:p>
             <a:pPr algn="ctr"/>
+            <a:endParaRPr/>
           </a:p>
         </p:txBody>
       </p:sp>
@@ -5505,7 +6061,7 @@
         </p:nvSpPr>
         <p:spPr>
           <a:xfrm>
-            <a:off x="365760" y="5760720"/>
+            <a:off x="274320" y="5802675"/>
             <a:ext cx="11338560" cy="640080"/>
           </a:xfrm>
           <a:prstGeom prst="rect">
@@ -5537,6 +6093,7 @@
           <a:lstStyle/>
           <a:p>
             <a:pPr algn="ctr"/>
+            <a:endParaRPr/>
           </a:p>
         </p:txBody>
       </p:sp>
@@ -5548,7 +6105,7 @@
         </p:nvSpPr>
         <p:spPr>
           <a:xfrm>
-            <a:off x="548640" y="5852160"/>
+            <a:off x="547295" y="5894115"/>
             <a:ext cx="10972800" cy="457200"/>
           </a:xfrm>
           <a:prstGeom prst="rect">
@@ -5564,13 +6121,34 @@
           <a:p>
             <a:pPr algn="ctr"/>
             <a:r>
-              <a:rPr sz="2000" b="1">
+              <a:rPr sz="2000" b="1" dirty="0" err="1">
                 <a:solidFill>
                   <a:srgbClr val="1E3A5F"/>
                 </a:solidFill>
               </a:rPr>
-              <a:t>費用: 5万円〜10万円　|　診断だけで終わってもOK</a:t>
-            </a:r>
+              <a:t>費用</a:t>
+            </a:r>
+            <a:r>
+              <a:rPr sz="2000" b="1" dirty="0">
+                <a:solidFill>
+                  <a:srgbClr val="1E3A5F"/>
+                </a:solidFill>
+              </a:rPr>
+              <a:t>: 5万円〜10万円　|　</a:t>
+            </a:r>
+            <a:r>
+              <a:rPr sz="2000" b="1" dirty="0" err="1">
+                <a:solidFill>
+                  <a:srgbClr val="1E3A5F"/>
+                </a:solidFill>
+              </a:rPr>
+              <a:t>診断だけで終わってもOK</a:t>
+            </a:r>
+            <a:endParaRPr sz="2000" b="1" dirty="0">
+              <a:solidFill>
+                <a:srgbClr val="1E3A5F"/>
+              </a:solidFill>
+            </a:endParaRPr>
           </a:p>
         </p:txBody>
       </p:sp>
@@ -5583,7 +6161,7 @@
 </file>
 
 <file path=ppt/slides/slide13.xml><?xml version="1.0" encoding="utf-8"?>
-<p:sld xmlns:a="http://schemas.openxmlformats.org/drawingml/2006/main" xmlns:p="http://schemas.openxmlformats.org/presentationml/2006/main" xmlns:r="http://schemas.openxmlformats.org/officeDocument/2006/relationships">
+<p:sld xmlns:a="http://schemas.openxmlformats.org/drawingml/2006/main" xmlns:r="http://schemas.openxmlformats.org/officeDocument/2006/relationships" xmlns:p="http://schemas.openxmlformats.org/presentationml/2006/main">
   <p:cSld>
     <p:spTree>
       <p:nvGrpSpPr>
@@ -5591,7 +6169,14 @@
         <p:cNvGrpSpPr/>
         <p:nvPr/>
       </p:nvGrpSpPr>
-      <p:grpSpPr/>
+      <p:grpSpPr>
+        <a:xfrm>
+          <a:off x="0" y="0"/>
+          <a:ext cx="0" cy="0"/>
+          <a:chOff x="0" y="0"/>
+          <a:chExt cx="0" cy="0"/>
+        </a:xfrm>
+      </p:grpSpPr>
       <p:sp>
         <p:nvSpPr>
           <p:cNvPr id="2" name="Rectangle 1"/>
@@ -5632,6 +6217,7 @@
           <a:lstStyle/>
           <a:p>
             <a:pPr algn="ctr"/>
+            <a:endParaRPr/>
           </a:p>
         </p:txBody>
       </p:sp>
@@ -5675,6 +6261,7 @@
           <a:lstStyle/>
           <a:p>
             <a:pPr algn="ctr"/>
+            <a:endParaRPr/>
           </a:p>
         </p:txBody>
       </p:sp>
@@ -5752,6 +6339,7 @@
           <a:lstStyle/>
           <a:p>
             <a:pPr algn="ctr"/>
+            <a:endParaRPr/>
           </a:p>
         </p:txBody>
       </p:sp>
@@ -5817,7 +6405,7 @@
               </a:spcBef>
             </a:pPr>
             <a:r>
-              <a:rPr sz="2200">
+              <a:rPr sz="2200" dirty="0">
                 <a:solidFill>
                   <a:srgbClr val="333333"/>
                 </a:solidFill>
@@ -5832,13 +6420,26 @@
               </a:spcBef>
             </a:pPr>
             <a:r>
-              <a:rPr sz="2200">
+              <a:rPr sz="2200" dirty="0">
                 <a:solidFill>
                   <a:srgbClr val="333333"/>
                 </a:solidFill>
               </a:rPr>
-              <a:t>② 山口県の人手不足に、AIは現実的な解決策</a:t>
-            </a:r>
+              <a:t>② </a:t>
+            </a:r>
+            <a:r>
+              <a:rPr sz="2200" dirty="0" err="1">
+                <a:solidFill>
+                  <a:srgbClr val="333333"/>
+                </a:solidFill>
+              </a:rPr>
+              <a:t>山口県の人手不足に、AIは現実的な解決策</a:t>
+            </a:r>
+            <a:endParaRPr sz="2200" dirty="0">
+              <a:solidFill>
+                <a:srgbClr val="333333"/>
+              </a:solidFill>
+            </a:endParaRPr>
           </a:p>
           <a:p>
             <a:pPr>
@@ -5847,13 +6448,26 @@
               </a:spcBef>
             </a:pPr>
             <a:r>
-              <a:rPr sz="2200">
+              <a:rPr sz="2200" dirty="0">
                 <a:solidFill>
                   <a:srgbClr val="333333"/>
                 </a:solidFill>
               </a:rPr>
-              <a:t>③ 製造・旅館・小売・建設で具体的な実績あり</a:t>
-            </a:r>
+              <a:t>③ </a:t>
+            </a:r>
+            <a:r>
+              <a:rPr sz="2200" dirty="0" err="1">
+                <a:solidFill>
+                  <a:srgbClr val="333333"/>
+                </a:solidFill>
+              </a:rPr>
+              <a:t>製造・旅館・小売・建設で具体的な実績あり</a:t>
+            </a:r>
+            <a:endParaRPr sz="2200" dirty="0">
+              <a:solidFill>
+                <a:srgbClr val="333333"/>
+              </a:solidFill>
+            </a:endParaRPr>
           </a:p>
           <a:p>
             <a:pPr>
@@ -5862,13 +6476,26 @@
               </a:spcBef>
             </a:pPr>
             <a:r>
-              <a:rPr sz="2200">
+              <a:rPr sz="2200" dirty="0">
                 <a:solidFill>
                   <a:srgbClr val="333333"/>
                 </a:solidFill>
               </a:rPr>
-              <a:t>④ 補助金を使えば自己負担を最小化できる</a:t>
-            </a:r>
+              <a:t>④ </a:t>
+            </a:r>
+            <a:r>
+              <a:rPr sz="2200" dirty="0" err="1">
+                <a:solidFill>
+                  <a:srgbClr val="333333"/>
+                </a:solidFill>
+              </a:rPr>
+              <a:t>補助金を使えば自己負担を最小化できる</a:t>
+            </a:r>
+            <a:endParaRPr sz="2200" dirty="0">
+              <a:solidFill>
+                <a:srgbClr val="333333"/>
+              </a:solidFill>
+            </a:endParaRPr>
           </a:p>
           <a:p>
             <a:pPr>
@@ -5877,12 +6504,28 @@
               </a:spcBef>
             </a:pPr>
             <a:r>
-              <a:rPr sz="2200">
+              <a:rPr sz="2200" dirty="0">
                 <a:solidFill>
                   <a:srgbClr val="333333"/>
                 </a:solidFill>
               </a:rPr>
-              <a:t>⑤ 最初の一歩は「AI業務診断」（5〜10万円）</a:t>
+              <a:t>⑤ </a:t>
+            </a:r>
+            <a:r>
+              <a:rPr sz="2200" dirty="0" err="1">
+                <a:solidFill>
+                  <a:srgbClr val="333333"/>
+                </a:solidFill>
+              </a:rPr>
+              <a:t>最初の一歩は「AI業務診断</a:t>
+            </a:r>
+            <a:r>
+              <a:rPr sz="2200" dirty="0">
+                <a:solidFill>
+                  <a:srgbClr val="333333"/>
+                </a:solidFill>
+              </a:rPr>
+              <a:t>」（5〜10万円）</a:t>
             </a:r>
           </a:p>
         </p:txBody>
@@ -5927,6 +6570,7 @@
           <a:lstStyle/>
           <a:p>
             <a:pPr algn="ctr"/>
+            <a:endParaRPr/>
           </a:p>
         </p:txBody>
       </p:sp>
@@ -5973,7 +6617,7 @@
 </file>
 
 <file path=ppt/slides/slide14.xml><?xml version="1.0" encoding="utf-8"?>
-<p:sld xmlns:a="http://schemas.openxmlformats.org/drawingml/2006/main" xmlns:p="http://schemas.openxmlformats.org/presentationml/2006/main" xmlns:r="http://schemas.openxmlformats.org/officeDocument/2006/relationships">
+<p:sld xmlns:a="http://schemas.openxmlformats.org/drawingml/2006/main" xmlns:r="http://schemas.openxmlformats.org/officeDocument/2006/relationships" xmlns:p="http://schemas.openxmlformats.org/presentationml/2006/main">
   <p:cSld>
     <p:spTree>
       <p:nvGrpSpPr>
@@ -5981,7 +6625,14 @@
         <p:cNvGrpSpPr/>
         <p:nvPr/>
       </p:nvGrpSpPr>
-      <p:grpSpPr/>
+      <p:grpSpPr>
+        <a:xfrm>
+          <a:off x="0" y="0"/>
+          <a:ext cx="0" cy="0"/>
+          <a:chOff x="0" y="0"/>
+          <a:chExt cx="0" cy="0"/>
+        </a:xfrm>
+      </p:grpSpPr>
       <p:sp>
         <p:nvSpPr>
           <p:cNvPr id="2" name="Rectangle 1"/>
@@ -6022,6 +6673,7 @@
           <a:lstStyle/>
           <a:p>
             <a:pPr algn="ctr"/>
+            <a:endParaRPr/>
           </a:p>
         </p:txBody>
       </p:sp>
@@ -6065,6 +6717,7 @@
           <a:lstStyle/>
           <a:p>
             <a:pPr algn="ctr"/>
+            <a:endParaRPr/>
           </a:p>
         </p:txBody>
       </p:sp>
@@ -6142,6 +6795,7 @@
           <a:lstStyle/>
           <a:p>
             <a:pPr algn="ctr"/>
+            <a:endParaRPr/>
           </a:p>
         </p:txBody>
       </p:sp>
@@ -6219,6 +6873,7 @@
           <a:lstStyle/>
           <a:p>
             <a:pPr algn="ctr"/>
+            <a:endParaRPr/>
           </a:p>
         </p:txBody>
       </p:sp>
@@ -6331,6 +6986,7 @@
           <a:lstStyle/>
           <a:p>
             <a:pPr algn="ctr"/>
+            <a:endParaRPr/>
           </a:p>
         </p:txBody>
       </p:sp>
@@ -6443,6 +7099,7 @@
           <a:lstStyle/>
           <a:p>
             <a:pPr algn="ctr"/>
+            <a:endParaRPr/>
           </a:p>
         </p:txBody>
       </p:sp>
@@ -6524,7 +7181,7 @@
 </file>
 
 <file path=ppt/slides/slide15.xml><?xml version="1.0" encoding="utf-8"?>
-<p:sld xmlns:a="http://schemas.openxmlformats.org/drawingml/2006/main" xmlns:p="http://schemas.openxmlformats.org/presentationml/2006/main" xmlns:r="http://schemas.openxmlformats.org/officeDocument/2006/relationships">
+<p:sld xmlns:a="http://schemas.openxmlformats.org/drawingml/2006/main" xmlns:r="http://schemas.openxmlformats.org/officeDocument/2006/relationships" xmlns:p="http://schemas.openxmlformats.org/presentationml/2006/main">
   <p:cSld>
     <p:spTree>
       <p:nvGrpSpPr>
@@ -6532,7 +7189,14 @@
         <p:cNvGrpSpPr/>
         <p:nvPr/>
       </p:nvGrpSpPr>
-      <p:grpSpPr/>
+      <p:grpSpPr>
+        <a:xfrm>
+          <a:off x="0" y="0"/>
+          <a:ext cx="0" cy="0"/>
+          <a:chOff x="0" y="0"/>
+          <a:chExt cx="0" cy="0"/>
+        </a:xfrm>
+      </p:grpSpPr>
       <p:sp>
         <p:nvSpPr>
           <p:cNvPr id="2" name="Rectangle 1"/>
@@ -6573,6 +7237,7 @@
           <a:lstStyle/>
           <a:p>
             <a:pPr algn="ctr"/>
+            <a:endParaRPr/>
           </a:p>
         </p:txBody>
       </p:sp>
@@ -6616,6 +7281,7 @@
           <a:lstStyle/>
           <a:p>
             <a:pPr algn="ctr"/>
+            <a:endParaRPr/>
           </a:p>
         </p:txBody>
       </p:sp>
@@ -6761,6 +7427,7 @@
           <a:lstStyle/>
           <a:p>
             <a:pPr algn="ctr"/>
+            <a:endParaRPr/>
           </a:p>
         </p:txBody>
       </p:sp>
@@ -6807,7 +7474,7 @@
 </file>
 
 <file path=ppt/slides/slide2.xml><?xml version="1.0" encoding="utf-8"?>
-<p:sld xmlns:a="http://schemas.openxmlformats.org/drawingml/2006/main" xmlns:p="http://schemas.openxmlformats.org/presentationml/2006/main" xmlns:r="http://schemas.openxmlformats.org/officeDocument/2006/relationships">
+<p:sld xmlns:a="http://schemas.openxmlformats.org/drawingml/2006/main" xmlns:r="http://schemas.openxmlformats.org/officeDocument/2006/relationships" xmlns:p="http://schemas.openxmlformats.org/presentationml/2006/main">
   <p:cSld>
     <p:spTree>
       <p:nvGrpSpPr>
@@ -6815,7 +7482,14 @@
         <p:cNvGrpSpPr/>
         <p:nvPr/>
       </p:nvGrpSpPr>
-      <p:grpSpPr/>
+      <p:grpSpPr>
+        <a:xfrm>
+          <a:off x="0" y="0"/>
+          <a:ext cx="0" cy="0"/>
+          <a:chOff x="0" y="0"/>
+          <a:chExt cx="0" cy="0"/>
+        </a:xfrm>
+      </p:grpSpPr>
       <p:sp>
         <p:nvSpPr>
           <p:cNvPr id="2" name="Rectangle 1"/>
@@ -6856,6 +7530,7 @@
           <a:lstStyle/>
           <a:p>
             <a:pPr algn="ctr"/>
+            <a:endParaRPr/>
           </a:p>
         </p:txBody>
       </p:sp>
@@ -6899,6 +7574,7 @@
           <a:lstStyle/>
           <a:p>
             <a:pPr algn="ctr"/>
+            <a:endParaRPr/>
           </a:p>
         </p:txBody>
       </p:sp>
@@ -6976,6 +7652,7 @@
           <a:lstStyle/>
           <a:p>
             <a:pPr algn="ctr"/>
+            <a:endParaRPr/>
           </a:p>
         </p:txBody>
       </p:sp>
@@ -7158,7 +7835,7 @@
 </file>
 
 <file path=ppt/slides/slide3.xml><?xml version="1.0" encoding="utf-8"?>
-<p:sld xmlns:a="http://schemas.openxmlformats.org/drawingml/2006/main" xmlns:p="http://schemas.openxmlformats.org/presentationml/2006/main" xmlns:r="http://schemas.openxmlformats.org/officeDocument/2006/relationships">
+<p:sld xmlns:a="http://schemas.openxmlformats.org/drawingml/2006/main" xmlns:r="http://schemas.openxmlformats.org/officeDocument/2006/relationships" xmlns:p="http://schemas.openxmlformats.org/presentationml/2006/main">
   <p:cSld>
     <p:spTree>
       <p:nvGrpSpPr>
@@ -7166,7 +7843,14 @@
         <p:cNvGrpSpPr/>
         <p:nvPr/>
       </p:nvGrpSpPr>
-      <p:grpSpPr/>
+      <p:grpSpPr>
+        <a:xfrm>
+          <a:off x="0" y="0"/>
+          <a:ext cx="0" cy="0"/>
+          <a:chOff x="0" y="0"/>
+          <a:chExt cx="0" cy="0"/>
+        </a:xfrm>
+      </p:grpSpPr>
       <p:sp>
         <p:nvSpPr>
           <p:cNvPr id="2" name="Rectangle 1"/>
@@ -7207,6 +7891,7 @@
           <a:lstStyle/>
           <a:p>
             <a:pPr algn="ctr"/>
+            <a:endParaRPr/>
           </a:p>
         </p:txBody>
       </p:sp>
@@ -7250,6 +7935,7 @@
           <a:lstStyle/>
           <a:p>
             <a:pPr algn="ctr"/>
+            <a:endParaRPr/>
           </a:p>
         </p:txBody>
       </p:sp>
@@ -7327,6 +8013,7 @@
           <a:lstStyle/>
           <a:p>
             <a:pPr algn="ctr"/>
+            <a:endParaRPr/>
           </a:p>
         </p:txBody>
       </p:sp>
@@ -7404,6 +8091,7 @@
           <a:lstStyle/>
           <a:p>
             <a:pPr algn="ctr"/>
+            <a:endParaRPr/>
           </a:p>
         </p:txBody>
       </p:sp>
@@ -7515,6 +8203,7 @@
           <a:lstStyle/>
           <a:p>
             <a:pPr algn="ctr"/>
+            <a:endParaRPr/>
           </a:p>
         </p:txBody>
       </p:sp>
@@ -7626,6 +8315,7 @@
           <a:lstStyle/>
           <a:p>
             <a:pPr algn="ctr"/>
+            <a:endParaRPr/>
           </a:p>
         </p:txBody>
       </p:sp>
@@ -7740,7 +8430,7 @@
 </file>
 
 <file path=ppt/slides/slide4.xml><?xml version="1.0" encoding="utf-8"?>
-<p:sld xmlns:a="http://schemas.openxmlformats.org/drawingml/2006/main" xmlns:p="http://schemas.openxmlformats.org/presentationml/2006/main" xmlns:r="http://schemas.openxmlformats.org/officeDocument/2006/relationships">
+<p:sld xmlns:a="http://schemas.openxmlformats.org/drawingml/2006/main" xmlns:r="http://schemas.openxmlformats.org/officeDocument/2006/relationships" xmlns:p="http://schemas.openxmlformats.org/presentationml/2006/main">
   <p:cSld>
     <p:spTree>
       <p:nvGrpSpPr>
@@ -7748,7 +8438,14 @@
         <p:cNvGrpSpPr/>
         <p:nvPr/>
       </p:nvGrpSpPr>
-      <p:grpSpPr/>
+      <p:grpSpPr>
+        <a:xfrm>
+          <a:off x="0" y="0"/>
+          <a:ext cx="0" cy="0"/>
+          <a:chOff x="0" y="0"/>
+          <a:chExt cx="0" cy="0"/>
+        </a:xfrm>
+      </p:grpSpPr>
       <p:sp>
         <p:nvSpPr>
           <p:cNvPr id="2" name="Rectangle 1"/>
@@ -7789,6 +8486,7 @@
           <a:lstStyle/>
           <a:p>
             <a:pPr algn="ctr"/>
+            <a:endParaRPr/>
           </a:p>
         </p:txBody>
       </p:sp>
@@ -7832,6 +8530,7 @@
           <a:lstStyle/>
           <a:p>
             <a:pPr algn="ctr"/>
+            <a:endParaRPr/>
           </a:p>
         </p:txBody>
       </p:sp>
@@ -7943,6 +8642,7 @@
           <a:lstStyle/>
           <a:p>
             <a:pPr algn="ctr"/>
+            <a:endParaRPr/>
           </a:p>
         </p:txBody>
       </p:sp>
@@ -8020,6 +8720,7 @@
           <a:lstStyle/>
           <a:p>
             <a:pPr algn="ctr"/>
+            <a:endParaRPr/>
           </a:p>
         </p:txBody>
       </p:sp>
@@ -8165,6 +8866,7 @@
           <a:lstStyle/>
           <a:p>
             <a:pPr algn="ctr"/>
+            <a:endParaRPr/>
           </a:p>
         </p:txBody>
       </p:sp>
@@ -8344,6 +9046,7 @@
           <a:lstStyle/>
           <a:p>
             <a:pPr algn="ctr"/>
+            <a:endParaRPr/>
           </a:p>
         </p:txBody>
       </p:sp>
@@ -8390,7 +9093,7 @@
 </file>
 
 <file path=ppt/slides/slide5.xml><?xml version="1.0" encoding="utf-8"?>
-<p:sld xmlns:a="http://schemas.openxmlformats.org/drawingml/2006/main" xmlns:p="http://schemas.openxmlformats.org/presentationml/2006/main" xmlns:r="http://schemas.openxmlformats.org/officeDocument/2006/relationships">
+<p:sld xmlns:a="http://schemas.openxmlformats.org/drawingml/2006/main" xmlns:r="http://schemas.openxmlformats.org/officeDocument/2006/relationships" xmlns:p="http://schemas.openxmlformats.org/presentationml/2006/main">
   <p:cSld>
     <p:spTree>
       <p:nvGrpSpPr>
@@ -8398,7 +9101,14 @@
         <p:cNvGrpSpPr/>
         <p:nvPr/>
       </p:nvGrpSpPr>
-      <p:grpSpPr/>
+      <p:grpSpPr>
+        <a:xfrm>
+          <a:off x="0" y="0"/>
+          <a:ext cx="0" cy="0"/>
+          <a:chOff x="0" y="0"/>
+          <a:chExt cx="0" cy="0"/>
+        </a:xfrm>
+      </p:grpSpPr>
       <p:sp>
         <p:nvSpPr>
           <p:cNvPr id="2" name="Rectangle 1"/>
@@ -8439,6 +9149,7 @@
           <a:lstStyle/>
           <a:p>
             <a:pPr algn="ctr"/>
+            <a:endParaRPr/>
           </a:p>
         </p:txBody>
       </p:sp>
@@ -8482,6 +9193,7 @@
           <a:lstStyle/>
           <a:p>
             <a:pPr algn="ctr"/>
+            <a:endParaRPr/>
           </a:p>
         </p:txBody>
       </p:sp>
@@ -8593,6 +9305,7 @@
           <a:lstStyle/>
           <a:p>
             <a:pPr algn="ctr"/>
+            <a:endParaRPr/>
           </a:p>
         </p:txBody>
       </p:sp>
@@ -8670,6 +9383,7 @@
           <a:lstStyle/>
           <a:p>
             <a:pPr algn="ctr"/>
+            <a:endParaRPr/>
           </a:p>
         </p:txBody>
       </p:sp>
@@ -8713,6 +9427,7 @@
           <a:lstStyle/>
           <a:p>
             <a:pPr algn="ctr"/>
+            <a:endParaRPr/>
           </a:p>
         </p:txBody>
       </p:sp>
@@ -8858,6 +9573,7 @@
           <a:lstStyle/>
           <a:p>
             <a:pPr algn="ctr"/>
+            <a:endParaRPr/>
           </a:p>
         </p:txBody>
       </p:sp>
@@ -8901,6 +9617,7 @@
           <a:lstStyle/>
           <a:p>
             <a:pPr algn="ctr"/>
+            <a:endParaRPr/>
           </a:p>
         </p:txBody>
       </p:sp>
@@ -9046,6 +9763,7 @@
           <a:lstStyle/>
           <a:p>
             <a:pPr algn="ctr"/>
+            <a:endParaRPr/>
           </a:p>
         </p:txBody>
       </p:sp>
@@ -9089,6 +9807,7 @@
           <a:lstStyle/>
           <a:p>
             <a:pPr algn="ctr"/>
+            <a:endParaRPr/>
           </a:p>
         </p:txBody>
       </p:sp>
@@ -9234,6 +9953,7 @@
           <a:lstStyle/>
           <a:p>
             <a:pPr algn="ctr"/>
+            <a:endParaRPr/>
           </a:p>
         </p:txBody>
       </p:sp>
@@ -9277,6 +9997,7 @@
           <a:lstStyle/>
           <a:p>
             <a:pPr algn="ctr"/>
+            <a:endParaRPr/>
           </a:p>
         </p:txBody>
       </p:sp>
@@ -9422,6 +10143,7 @@
           <a:lstStyle/>
           <a:p>
             <a:pPr algn="ctr"/>
+            <a:endParaRPr/>
           </a:p>
         </p:txBody>
       </p:sp>
@@ -9468,7 +10190,7 @@
 </file>
 
 <file path=ppt/slides/slide6.xml><?xml version="1.0" encoding="utf-8"?>
-<p:sld xmlns:a="http://schemas.openxmlformats.org/drawingml/2006/main" xmlns:p="http://schemas.openxmlformats.org/presentationml/2006/main" xmlns:r="http://schemas.openxmlformats.org/officeDocument/2006/relationships">
+<p:sld xmlns:a="http://schemas.openxmlformats.org/drawingml/2006/main" xmlns:r="http://schemas.openxmlformats.org/officeDocument/2006/relationships" xmlns:p="http://schemas.openxmlformats.org/presentationml/2006/main">
   <p:cSld>
     <p:spTree>
       <p:nvGrpSpPr>
@@ -9476,7 +10198,14 @@
         <p:cNvGrpSpPr/>
         <p:nvPr/>
       </p:nvGrpSpPr>
-      <p:grpSpPr/>
+      <p:grpSpPr>
+        <a:xfrm>
+          <a:off x="0" y="0"/>
+          <a:ext cx="0" cy="0"/>
+          <a:chOff x="0" y="0"/>
+          <a:chExt cx="0" cy="0"/>
+        </a:xfrm>
+      </p:grpSpPr>
       <p:sp>
         <p:nvSpPr>
           <p:cNvPr id="2" name="Rectangle 1"/>
@@ -9517,6 +10246,7 @@
           <a:lstStyle/>
           <a:p>
             <a:pPr algn="ctr"/>
+            <a:endParaRPr/>
           </a:p>
         </p:txBody>
       </p:sp>
@@ -9560,6 +10290,7 @@
           <a:lstStyle/>
           <a:p>
             <a:pPr algn="ctr"/>
+            <a:endParaRPr/>
           </a:p>
         </p:txBody>
       </p:sp>
@@ -9671,6 +10402,7 @@
           <a:lstStyle/>
           <a:p>
             <a:pPr algn="ctr"/>
+            <a:endParaRPr/>
           </a:p>
         </p:txBody>
       </p:sp>
@@ -9782,6 +10514,7 @@
           <a:lstStyle/>
           <a:p>
             <a:pPr algn="ctr"/>
+            <a:endParaRPr/>
           </a:p>
         </p:txBody>
       </p:sp>
@@ -9897,7 +10630,7 @@
 </file>
 
 <file path=ppt/slides/slide7.xml><?xml version="1.0" encoding="utf-8"?>
-<p:sld xmlns:a="http://schemas.openxmlformats.org/drawingml/2006/main" xmlns:p="http://schemas.openxmlformats.org/presentationml/2006/main" xmlns:r="http://schemas.openxmlformats.org/officeDocument/2006/relationships">
+<p:sld xmlns:a="http://schemas.openxmlformats.org/drawingml/2006/main" xmlns:r="http://schemas.openxmlformats.org/officeDocument/2006/relationships" xmlns:p="http://schemas.openxmlformats.org/presentationml/2006/main">
   <p:cSld>
     <p:spTree>
       <p:nvGrpSpPr>
@@ -9905,7 +10638,14 @@
         <p:cNvGrpSpPr/>
         <p:nvPr/>
       </p:nvGrpSpPr>
-      <p:grpSpPr/>
+      <p:grpSpPr>
+        <a:xfrm>
+          <a:off x="0" y="0"/>
+          <a:ext cx="0" cy="0"/>
+          <a:chOff x="0" y="0"/>
+          <a:chExt cx="0" cy="0"/>
+        </a:xfrm>
+      </p:grpSpPr>
       <p:sp>
         <p:nvSpPr>
           <p:cNvPr id="2" name="Rectangle 1"/>
@@ -9946,6 +10686,7 @@
           <a:lstStyle/>
           <a:p>
             <a:pPr algn="ctr"/>
+            <a:endParaRPr/>
           </a:p>
         </p:txBody>
       </p:sp>
@@ -9989,6 +10730,7 @@
           <a:lstStyle/>
           <a:p>
             <a:pPr algn="ctr"/>
+            <a:endParaRPr/>
           </a:p>
         </p:txBody>
       </p:sp>
@@ -10066,6 +10808,7 @@
           <a:lstStyle/>
           <a:p>
             <a:pPr algn="ctr"/>
+            <a:endParaRPr/>
           </a:p>
         </p:txBody>
       </p:sp>
@@ -10211,6 +10954,7 @@
           <a:lstStyle/>
           <a:p>
             <a:pPr algn="ctr"/>
+            <a:endParaRPr/>
           </a:p>
         </p:txBody>
       </p:sp>
@@ -10292,7 +11036,7 @@
 </file>
 
 <file path=ppt/slides/slide8.xml><?xml version="1.0" encoding="utf-8"?>
-<p:sld xmlns:a="http://schemas.openxmlformats.org/drawingml/2006/main" xmlns:p="http://schemas.openxmlformats.org/presentationml/2006/main" xmlns:r="http://schemas.openxmlformats.org/officeDocument/2006/relationships">
+<p:sld xmlns:a="http://schemas.openxmlformats.org/drawingml/2006/main" xmlns:r="http://schemas.openxmlformats.org/officeDocument/2006/relationships" xmlns:p="http://schemas.openxmlformats.org/presentationml/2006/main">
   <p:cSld>
     <p:spTree>
       <p:nvGrpSpPr>
@@ -10300,7 +11044,14 @@
         <p:cNvGrpSpPr/>
         <p:nvPr/>
       </p:nvGrpSpPr>
-      <p:grpSpPr/>
+      <p:grpSpPr>
+        <a:xfrm>
+          <a:off x="0" y="0"/>
+          <a:ext cx="0" cy="0"/>
+          <a:chOff x="0" y="0"/>
+          <a:chExt cx="0" cy="0"/>
+        </a:xfrm>
+      </p:grpSpPr>
       <p:sp>
         <p:nvSpPr>
           <p:cNvPr id="2" name="Rectangle 1"/>
@@ -10341,6 +11092,7 @@
           <a:lstStyle/>
           <a:p>
             <a:pPr algn="ctr"/>
+            <a:endParaRPr/>
           </a:p>
         </p:txBody>
       </p:sp>
@@ -10384,6 +11136,7 @@
           <a:lstStyle/>
           <a:p>
             <a:pPr algn="ctr"/>
+            <a:endParaRPr/>
           </a:p>
         </p:txBody>
       </p:sp>
@@ -10461,6 +11214,7 @@
           <a:lstStyle/>
           <a:p>
             <a:pPr algn="ctr"/>
+            <a:endParaRPr/>
           </a:p>
         </p:txBody>
       </p:sp>
@@ -10538,6 +11292,7 @@
           <a:lstStyle/>
           <a:p>
             <a:pPr algn="ctr"/>
+            <a:endParaRPr/>
           </a:p>
         </p:txBody>
       </p:sp>
@@ -10698,6 +11453,7 @@
           <a:lstStyle/>
           <a:p>
             <a:pPr algn="ctr"/>
+            <a:endParaRPr/>
           </a:p>
         </p:txBody>
       </p:sp>
@@ -10858,6 +11614,7 @@
           <a:lstStyle/>
           <a:p>
             <a:pPr algn="ctr"/>
+            <a:endParaRPr/>
           </a:p>
         </p:txBody>
       </p:sp>
@@ -10904,7 +11661,7 @@
 </file>
 
 <file path=ppt/slides/slide9.xml><?xml version="1.0" encoding="utf-8"?>
-<p:sld xmlns:a="http://schemas.openxmlformats.org/drawingml/2006/main" xmlns:p="http://schemas.openxmlformats.org/presentationml/2006/main" xmlns:r="http://schemas.openxmlformats.org/officeDocument/2006/relationships">
+<p:sld xmlns:a="http://schemas.openxmlformats.org/drawingml/2006/main" xmlns:r="http://schemas.openxmlformats.org/officeDocument/2006/relationships" xmlns:p="http://schemas.openxmlformats.org/presentationml/2006/main">
   <p:cSld>
     <p:spTree>
       <p:nvGrpSpPr>
@@ -10912,7 +11669,14 @@
         <p:cNvGrpSpPr/>
         <p:nvPr/>
       </p:nvGrpSpPr>
-      <p:grpSpPr/>
+      <p:grpSpPr>
+        <a:xfrm>
+          <a:off x="0" y="0"/>
+          <a:ext cx="0" cy="0"/>
+          <a:chOff x="0" y="0"/>
+          <a:chExt cx="0" cy="0"/>
+        </a:xfrm>
+      </p:grpSpPr>
       <p:sp>
         <p:nvSpPr>
           <p:cNvPr id="2" name="Rectangle 1"/>
@@ -10953,6 +11717,7 @@
           <a:lstStyle/>
           <a:p>
             <a:pPr algn="ctr"/>
+            <a:endParaRPr/>
           </a:p>
         </p:txBody>
       </p:sp>
@@ -10996,6 +11761,7 @@
           <a:lstStyle/>
           <a:p>
             <a:pPr algn="ctr"/>
+            <a:endParaRPr/>
           </a:p>
         </p:txBody>
       </p:sp>
@@ -11073,6 +11839,7 @@
           <a:lstStyle/>
           <a:p>
             <a:pPr algn="ctr"/>
+            <a:endParaRPr/>
           </a:p>
         </p:txBody>
       </p:sp>
@@ -11150,6 +11917,7 @@
           <a:lstStyle/>
           <a:p>
             <a:pPr algn="ctr"/>
+            <a:endParaRPr/>
           </a:p>
         </p:txBody>
       </p:sp>
@@ -11310,6 +12078,7 @@
           <a:lstStyle/>
           <a:p>
             <a:pPr algn="ctr"/>
+            <a:endParaRPr/>
           </a:p>
         </p:txBody>
       </p:sp>
@@ -11756,4 +12525,319 @@
   </a:objectDefaults>
   <a:extraClrSchemeLst/>
 </a:theme>
+</file>
+
+<file path=ppt/theme/theme2.xml><?xml version="1.0" encoding="utf-8"?>
+<a:theme xmlns:a="http://schemas.openxmlformats.org/drawingml/2006/main" name="Office テーマ">
+  <a:themeElements>
+    <a:clrScheme name="Office">
+      <a:dk1>
+        <a:sysClr val="windowText" lastClr="000000"/>
+      </a:dk1>
+      <a:lt1>
+        <a:sysClr val="window" lastClr="FFFFFF"/>
+      </a:lt1>
+      <a:dk2>
+        <a:srgbClr val="0E2841"/>
+      </a:dk2>
+      <a:lt2>
+        <a:srgbClr val="E8E8E8"/>
+      </a:lt2>
+      <a:accent1>
+        <a:srgbClr val="156082"/>
+      </a:accent1>
+      <a:accent2>
+        <a:srgbClr val="E97132"/>
+      </a:accent2>
+      <a:accent3>
+        <a:srgbClr val="196B24"/>
+      </a:accent3>
+      <a:accent4>
+        <a:srgbClr val="0F9ED5"/>
+      </a:accent4>
+      <a:accent5>
+        <a:srgbClr val="A02B93"/>
+      </a:accent5>
+      <a:accent6>
+        <a:srgbClr val="4EA72E"/>
+      </a:accent6>
+      <a:hlink>
+        <a:srgbClr val="467886"/>
+      </a:hlink>
+      <a:folHlink>
+        <a:srgbClr val="96607D"/>
+      </a:folHlink>
+    </a:clrScheme>
+    <a:fontScheme name="Office">
+      <a:majorFont>
+        <a:latin typeface="游ゴシック Light" panose="02110004020202020204"/>
+        <a:ea typeface=""/>
+        <a:cs typeface=""/>
+        <a:font script="Jpan" typeface="游ゴシック Light"/>
+        <a:font script="Hang" typeface="맑은 고딕"/>
+        <a:font script="Hans" typeface="等线 Light"/>
+        <a:font script="Hant" typeface="新細明體"/>
+        <a:font script="Arab" typeface="Times New Roman"/>
+        <a:font script="Hebr" typeface="Times New Roman"/>
+        <a:font script="Thai" typeface="Angsana New"/>
+        <a:font script="Ethi" typeface="Nyala"/>
+        <a:font script="Beng" typeface="Vrinda"/>
+        <a:font script="Gujr" typeface="Shruti"/>
+        <a:font script="Khmr" typeface="MoolBoran"/>
+        <a:font script="Knda" typeface="Tunga"/>
+        <a:font script="Guru" typeface="Raavi"/>
+        <a:font script="Cans" typeface="Euphemia"/>
+        <a:font script="Cher" typeface="Plantagenet Cherokee"/>
+        <a:font script="Yiii" typeface="Microsoft Yi Baiti"/>
+        <a:font script="Tibt" typeface="Microsoft Himalaya"/>
+        <a:font script="Thaa" typeface="MV Boli"/>
+        <a:font script="Deva" typeface="Mangal"/>
+        <a:font script="Telu" typeface="Gautami"/>
+        <a:font script="Taml" typeface="Latha"/>
+        <a:font script="Syrc" typeface="Estrangelo Edessa"/>
+        <a:font script="Orya" typeface="Kalinga"/>
+        <a:font script="Mlym" typeface="Kartika"/>
+        <a:font script="Laoo" typeface="DokChampa"/>
+        <a:font script="Sinh" typeface="Iskoola Pota"/>
+        <a:font script="Mong" typeface="Mongolian Baiti"/>
+        <a:font script="Viet" typeface="Times New Roman"/>
+        <a:font script="Uigh" typeface="Microsoft Uighur"/>
+        <a:font script="Geor" typeface="Sylfaen"/>
+        <a:font script="Armn" typeface="Arial"/>
+        <a:font script="Bugi" typeface="Leelawadee UI"/>
+        <a:font script="Bopo" typeface="Microsoft JhengHei"/>
+        <a:font script="Java" typeface="Javanese Text"/>
+        <a:font script="Lisu" typeface="Segoe UI"/>
+        <a:font script="Mymr" typeface="Myanmar Text"/>
+        <a:font script="Nkoo" typeface="Ebrima"/>
+        <a:font script="Olck" typeface="Nirmala UI"/>
+        <a:font script="Osma" typeface="Ebrima"/>
+        <a:font script="Phag" typeface="Phagspa"/>
+        <a:font script="Syrn" typeface="Estrangelo Edessa"/>
+        <a:font script="Syrj" typeface="Estrangelo Edessa"/>
+        <a:font script="Syre" typeface="Estrangelo Edessa"/>
+        <a:font script="Sora" typeface="Nirmala UI"/>
+        <a:font script="Tale" typeface="Microsoft Tai Le"/>
+        <a:font script="Talu" typeface="Microsoft New Tai Lue"/>
+        <a:font script="Tfng" typeface="Ebrima"/>
+      </a:majorFont>
+      <a:minorFont>
+        <a:latin typeface="游ゴシック" panose="02110004020202020204"/>
+        <a:ea typeface=""/>
+        <a:cs typeface=""/>
+        <a:font script="Jpan" typeface="游ゴシック"/>
+        <a:font script="Hang" typeface="맑은 고딕"/>
+        <a:font script="Hans" typeface="等线"/>
+        <a:font script="Hant" typeface="新細明體"/>
+        <a:font script="Arab" typeface="Arial"/>
+        <a:font script="Hebr" typeface="Arial"/>
+        <a:font script="Thai" typeface="Cordia New"/>
+        <a:font script="Ethi" typeface="Nyala"/>
+        <a:font script="Beng" typeface="Vrinda"/>
+        <a:font script="Gujr" typeface="Shruti"/>
+        <a:font script="Khmr" typeface="DaunPenh"/>
+        <a:font script="Knda" typeface="Tunga"/>
+        <a:font script="Guru" typeface="Raavi"/>
+        <a:font script="Cans" typeface="Euphemia"/>
+        <a:font script="Cher" typeface="Plantagenet Cherokee"/>
+        <a:font script="Yiii" typeface="Microsoft Yi Baiti"/>
+        <a:font script="Tibt" typeface="Microsoft Himalaya"/>
+        <a:font script="Thaa" typeface="MV Boli"/>
+        <a:font script="Deva" typeface="Mangal"/>
+        <a:font script="Telu" typeface="Gautami"/>
+        <a:font script="Taml" typeface="Latha"/>
+        <a:font script="Syrc" typeface="Estrangelo Edessa"/>
+        <a:font script="Orya" typeface="Kalinga"/>
+        <a:font script="Mlym" typeface="Kartika"/>
+        <a:font script="Laoo" typeface="DokChampa"/>
+        <a:font script="Sinh" typeface="Iskoola Pota"/>
+        <a:font script="Mong" typeface="Mongolian Baiti"/>
+        <a:font script="Viet" typeface="Arial"/>
+        <a:font script="Uigh" typeface="Microsoft Uighur"/>
+        <a:font script="Geor" typeface="Sylfaen"/>
+        <a:font script="Armn" typeface="Arial"/>
+        <a:font script="Bugi" typeface="Leelawadee UI"/>
+        <a:font script="Bopo" typeface="Microsoft JhengHei"/>
+        <a:font script="Java" typeface="Javanese Text"/>
+        <a:font script="Lisu" typeface="Segoe UI"/>
+        <a:font script="Mymr" typeface="Myanmar Text"/>
+        <a:font script="Nkoo" typeface="Ebrima"/>
+        <a:font script="Olck" typeface="Nirmala UI"/>
+        <a:font script="Osma" typeface="Ebrima"/>
+        <a:font script="Phag" typeface="Phagspa"/>
+        <a:font script="Syrn" typeface="Estrangelo Edessa"/>
+        <a:font script="Syrj" typeface="Estrangelo Edessa"/>
+        <a:font script="Syre" typeface="Estrangelo Edessa"/>
+        <a:font script="Sora" typeface="Nirmala UI"/>
+        <a:font script="Tale" typeface="Microsoft Tai Le"/>
+        <a:font script="Talu" typeface="Microsoft New Tai Lue"/>
+        <a:font script="Tfng" typeface="Ebrima"/>
+      </a:minorFont>
+    </a:fontScheme>
+    <a:fmtScheme name="Office">
+      <a:fillStyleLst>
+        <a:solidFill>
+          <a:schemeClr val="phClr"/>
+        </a:solidFill>
+        <a:gradFill rotWithShape="1">
+          <a:gsLst>
+            <a:gs pos="0">
+              <a:schemeClr val="phClr">
+                <a:lumMod val="110000"/>
+                <a:satMod val="105000"/>
+                <a:tint val="67000"/>
+              </a:schemeClr>
+            </a:gs>
+            <a:gs pos="50000">
+              <a:schemeClr val="phClr">
+                <a:lumMod val="105000"/>
+                <a:satMod val="103000"/>
+                <a:tint val="73000"/>
+              </a:schemeClr>
+            </a:gs>
+            <a:gs pos="100000">
+              <a:schemeClr val="phClr">
+                <a:lumMod val="105000"/>
+                <a:satMod val="109000"/>
+                <a:tint val="81000"/>
+              </a:schemeClr>
+            </a:gs>
+          </a:gsLst>
+          <a:lin ang="5400000" scaled="0"/>
+        </a:gradFill>
+        <a:gradFill rotWithShape="1">
+          <a:gsLst>
+            <a:gs pos="0">
+              <a:schemeClr val="phClr">
+                <a:satMod val="103000"/>
+                <a:lumMod val="102000"/>
+                <a:tint val="94000"/>
+              </a:schemeClr>
+            </a:gs>
+            <a:gs pos="50000">
+              <a:schemeClr val="phClr">
+                <a:satMod val="110000"/>
+                <a:lumMod val="100000"/>
+                <a:shade val="100000"/>
+              </a:schemeClr>
+            </a:gs>
+            <a:gs pos="100000">
+              <a:schemeClr val="phClr">
+                <a:lumMod val="99000"/>
+                <a:satMod val="120000"/>
+                <a:shade val="78000"/>
+              </a:schemeClr>
+            </a:gs>
+          </a:gsLst>
+          <a:lin ang="5400000" scaled="0"/>
+        </a:gradFill>
+      </a:fillStyleLst>
+      <a:lnStyleLst>
+        <a:ln w="12700" cap="flat" cmpd="sng" algn="ctr">
+          <a:solidFill>
+            <a:schemeClr val="phClr"/>
+          </a:solidFill>
+          <a:prstDash val="solid"/>
+          <a:miter lim="800000"/>
+        </a:ln>
+        <a:ln w="19050" cap="flat" cmpd="sng" algn="ctr">
+          <a:solidFill>
+            <a:schemeClr val="phClr"/>
+          </a:solidFill>
+          <a:prstDash val="solid"/>
+          <a:miter lim="800000"/>
+        </a:ln>
+        <a:ln w="25400" cap="flat" cmpd="sng" algn="ctr">
+          <a:solidFill>
+            <a:schemeClr val="phClr"/>
+          </a:solidFill>
+          <a:prstDash val="solid"/>
+          <a:miter lim="800000"/>
+        </a:ln>
+      </a:lnStyleLst>
+      <a:effectStyleLst>
+        <a:effectStyle>
+          <a:effectLst/>
+        </a:effectStyle>
+        <a:effectStyle>
+          <a:effectLst/>
+        </a:effectStyle>
+        <a:effectStyle>
+          <a:effectLst>
+            <a:outerShdw blurRad="57150" dist="19050" dir="5400000" algn="ctr" rotWithShape="0">
+              <a:srgbClr val="000000">
+                <a:alpha val="63000"/>
+              </a:srgbClr>
+            </a:outerShdw>
+          </a:effectLst>
+        </a:effectStyle>
+      </a:effectStyleLst>
+      <a:bgFillStyleLst>
+        <a:solidFill>
+          <a:schemeClr val="phClr"/>
+        </a:solidFill>
+        <a:solidFill>
+          <a:schemeClr val="phClr">
+            <a:tint val="95000"/>
+            <a:satMod val="170000"/>
+          </a:schemeClr>
+        </a:solidFill>
+        <a:gradFill rotWithShape="1">
+          <a:gsLst>
+            <a:gs pos="0">
+              <a:schemeClr val="phClr">
+                <a:tint val="93000"/>
+                <a:satMod val="150000"/>
+                <a:shade val="98000"/>
+                <a:lumMod val="102000"/>
+              </a:schemeClr>
+            </a:gs>
+            <a:gs pos="50000">
+              <a:schemeClr val="phClr">
+                <a:tint val="98000"/>
+                <a:satMod val="130000"/>
+                <a:shade val="90000"/>
+                <a:lumMod val="103000"/>
+              </a:schemeClr>
+            </a:gs>
+            <a:gs pos="100000">
+              <a:schemeClr val="phClr">
+                <a:shade val="63000"/>
+                <a:satMod val="120000"/>
+              </a:schemeClr>
+            </a:gs>
+          </a:gsLst>
+          <a:lin ang="5400000" scaled="0"/>
+        </a:gradFill>
+      </a:bgFillStyleLst>
+    </a:fmtScheme>
+  </a:themeElements>
+  <a:objectDefaults>
+    <a:lnDef>
+      <a:spPr/>
+      <a:bodyPr/>
+      <a:lstStyle/>
+      <a:style>
+        <a:lnRef idx="2">
+          <a:schemeClr val="accent1"/>
+        </a:lnRef>
+        <a:fillRef idx="0">
+          <a:schemeClr val="accent1"/>
+        </a:fillRef>
+        <a:effectRef idx="1">
+          <a:schemeClr val="accent1"/>
+        </a:effectRef>
+        <a:fontRef idx="minor">
+          <a:schemeClr val="tx1"/>
+        </a:fontRef>
+      </a:style>
+    </a:lnDef>
+  </a:objectDefaults>
+  <a:extraClrSchemeLst/>
+  <a:extLst>
+    <a:ext uri="{05A4C25C-085E-4340-85A3-A5531E510DB2}">
+      <thm15:themeFamily xmlns:thm15="http://schemas.microsoft.com/office/thememl/2012/main" name="Office Theme" id="{2E142A2C-CD16-42D6-873A-C26D2A0506FA}" vid="{1BDDFF52-6CD6-40A5-AB3C-68EB2F1E4D0A}"/>
+    </a:ext>
+  </a:extLst>
+</a:theme>
 </file>
</xml_diff>